<commit_message>
Fix dashboard contrast and enrich presentation
</commit_message>
<xml_diff>
--- a/presentation/renewable_operations_demo.pptx
+++ b/presentation/renewable_operations_demo.pptx
@@ -1278,7 +1278,7 @@
           <a:lstStyle/>
           <a:p>
             <a:r>
-              <a:t>Mensaje principal: Mostrar un resumen real del dataset validado sin inventar cifras.</a:t>
+              <a:t>Mensaje principal: Mostrar el dashboard real corregido y explicar las dos series y los filtros.</a:t>
             </a:r>
           </a:p>
           <a:p>
@@ -12581,7 +12581,7 @@
                 </a:solidFill>
                 <a:latin typeface="Aptos"/>
               </a:rPr>
-              <a:t>Resultados del despliegue remoto validados</a:t>
+              <a:t>Captura real del dashboard AI/BI publicado · paleta validada en tema oscuro</a:t>
             </a:r>
           </a:p>
         </p:txBody>
@@ -12664,14 +12664,14 @@
         </p:nvSpPr>
         <p:spPr>
           <a:xfrm>
-            <a:off x="685800" y="1234440"/>
-            <a:ext cx="2560320" cy="1325880"/>
+            <a:off x="594360" y="1115568"/>
+            <a:ext cx="11009376" cy="4946903"/>
           </a:xfrm>
           <a:prstGeom prst="roundRect">
             <a:avLst/>
           </a:prstGeom>
           <a:solidFill>
-            <a:srgbClr val="F5F7F9"/>
+            <a:srgbClr val="FFFFFF"/>
           </a:solidFill>
           <a:ln w="12700">
             <a:solidFill>
@@ -12701,16 +12701,40 @@
           </a:p>
         </p:txBody>
       </p:sp>
-      <p:sp>
-        <p:nvSpPr>
-          <p:cNvPr id="8" name="TextBox 7"/>
+      <p:pic>
+        <p:nvPicPr>
+          <p:cNvPr id="8" name="Picture 7" descr="image.png"/>
+          <p:cNvPicPr>
+            <a:picLocks noChangeAspect="1"/>
+          </p:cNvPicPr>
+          <p:nvPr/>
+        </p:nvPicPr>
+        <p:blipFill>
+          <a:blip r:embed="rId2"/>
+          <a:stretch>
+            <a:fillRect/>
+          </a:stretch>
+        </p:blipFill>
+        <p:spPr>
+          <a:xfrm>
+            <a:off x="621792" y="1143000"/>
+            <a:ext cx="10954512" cy="4892040"/>
+          </a:xfrm>
+          <a:prstGeom prst="rect">
+            <a:avLst/>
+          </a:prstGeom>
+        </p:spPr>
+      </p:pic>
+      <p:sp>
+        <p:nvSpPr>
+          <p:cNvPr id="9" name="TextBox 8"/>
           <p:cNvSpPr txBox="1"/>
           <p:nvPr/>
         </p:nvSpPr>
         <p:spPr>
           <a:xfrm>
-            <a:off x="822960" y="1389888"/>
-            <a:ext cx="2286000" cy="274320"/>
+            <a:off x="749808" y="6080760"/>
+            <a:ext cx="10652760" cy="219456"/>
           </a:xfrm>
           <a:prstGeom prst="rect">
             <a:avLst/>
@@ -12723,1913 +12747,15 @@
           </a:bodyPr>
           <a:lstStyle/>
           <a:p>
-            <a:pPr algn="l"/>
-            <a:r>
-              <a:rPr sz="1100" b="0">
+            <a:pPr algn="ctr"/>
+            <a:r>
+              <a:rPr sz="1000" b="0">
                 <a:solidFill>
                   <a:srgbClr val="6B7785"/>
                 </a:solidFill>
                 <a:latin typeface="Aptos"/>
               </a:rPr>
-              <a:t>Generación</a:t>
-            </a:r>
-          </a:p>
-        </p:txBody>
-      </p:sp>
-      <p:sp>
-        <p:nvSpPr>
-          <p:cNvPr id="9" name="TextBox 8"/>
-          <p:cNvSpPr txBox="1"/>
-          <p:nvPr/>
-        </p:nvSpPr>
-        <p:spPr>
-          <a:xfrm>
-            <a:off x="822960" y="1719072"/>
-            <a:ext cx="2286000" cy="502920"/>
-          </a:xfrm>
-          <a:prstGeom prst="rect">
-            <a:avLst/>
-          </a:prstGeom>
-          <a:noFill/>
-        </p:spPr>
-        <p:txBody>
-          <a:bodyPr wrap="square" anchor="ctr">
-            <a:spAutoFit/>
-          </a:bodyPr>
-          <a:lstStyle/>
-          <a:p>
-            <a:pPr algn="l"/>
-            <a:r>
-              <a:rPr sz="1900" b="1">
-                <a:solidFill>
-                  <a:srgbClr val="00A972"/>
-                </a:solidFill>
-                <a:latin typeface="Aptos"/>
-              </a:rPr>
-              <a:t>3.80 M MWh</a:t>
-            </a:r>
-          </a:p>
-        </p:txBody>
-      </p:sp>
-      <p:sp>
-        <p:nvSpPr>
-          <p:cNvPr id="10" name="Rounded Rectangle 9"/>
-          <p:cNvSpPr/>
-          <p:nvPr/>
-        </p:nvSpPr>
-        <p:spPr>
-          <a:xfrm>
-            <a:off x="3474720" y="1234440"/>
-            <a:ext cx="2560320" cy="1325880"/>
-          </a:xfrm>
-          <a:prstGeom prst="roundRect">
-            <a:avLst/>
-          </a:prstGeom>
-          <a:solidFill>
-            <a:srgbClr val="F5F7F9"/>
-          </a:solidFill>
-          <a:ln w="12700">
-            <a:solidFill>
-              <a:srgbClr val="D9DFE5"/>
-            </a:solidFill>
-          </a:ln>
-        </p:spPr>
-        <p:style>
-          <a:lnRef idx="1">
-            <a:schemeClr val="accent1"/>
-          </a:lnRef>
-          <a:fillRef idx="3">
-            <a:schemeClr val="accent1"/>
-          </a:fillRef>
-          <a:effectRef idx="2">
-            <a:schemeClr val="accent1"/>
-          </a:effectRef>
-          <a:fontRef idx="minor">
-            <a:schemeClr val="lt1"/>
-          </a:fontRef>
-        </p:style>
-        <p:txBody>
-          <a:bodyPr rtlCol="0" anchor="ctr"/>
-          <a:lstStyle/>
-          <a:p>
-            <a:pPr algn="ctr"/>
-          </a:p>
-        </p:txBody>
-      </p:sp>
-      <p:sp>
-        <p:nvSpPr>
-          <p:cNvPr id="11" name="TextBox 10"/>
-          <p:cNvSpPr txBox="1"/>
-          <p:nvPr/>
-        </p:nvSpPr>
-        <p:spPr>
-          <a:xfrm>
-            <a:off x="3611879" y="1389888"/>
-            <a:ext cx="2286000" cy="274320"/>
-          </a:xfrm>
-          <a:prstGeom prst="rect">
-            <a:avLst/>
-          </a:prstGeom>
-          <a:noFill/>
-        </p:spPr>
-        <p:txBody>
-          <a:bodyPr wrap="square" anchor="ctr">
-            <a:spAutoFit/>
-          </a:bodyPr>
-          <a:lstStyle/>
-          <a:p>
-            <a:pPr algn="l"/>
-            <a:r>
-              <a:rPr sz="1100" b="0">
-                <a:solidFill>
-                  <a:srgbClr val="6B7785"/>
-                </a:solidFill>
-                <a:latin typeface="Aptos"/>
-              </a:rPr>
-              <a:t>Desviación</a:t>
-            </a:r>
-          </a:p>
-        </p:txBody>
-      </p:sp>
-      <p:sp>
-        <p:nvSpPr>
-          <p:cNvPr id="12" name="TextBox 11"/>
-          <p:cNvSpPr txBox="1"/>
-          <p:nvPr/>
-        </p:nvSpPr>
-        <p:spPr>
-          <a:xfrm>
-            <a:off x="3611879" y="1719072"/>
-            <a:ext cx="2286000" cy="502920"/>
-          </a:xfrm>
-          <a:prstGeom prst="rect">
-            <a:avLst/>
-          </a:prstGeom>
-          <a:noFill/>
-        </p:spPr>
-        <p:txBody>
-          <a:bodyPr wrap="square" anchor="ctr">
-            <a:spAutoFit/>
-          </a:bodyPr>
-          <a:lstStyle/>
-          <a:p>
-            <a:pPr algn="l"/>
-            <a:r>
-              <a:rPr sz="1900" b="1">
-                <a:solidFill>
-                  <a:srgbClr val="FF3621"/>
-                </a:solidFill>
-                <a:latin typeface="Aptos"/>
-              </a:rPr>
-              <a:t>-57.9 k MWh</a:t>
-            </a:r>
-          </a:p>
-        </p:txBody>
-      </p:sp>
-      <p:sp>
-        <p:nvSpPr>
-          <p:cNvPr id="13" name="Rounded Rectangle 12"/>
-          <p:cNvSpPr/>
-          <p:nvPr/>
-        </p:nvSpPr>
-        <p:spPr>
-          <a:xfrm>
-            <a:off x="6263640" y="1234440"/>
-            <a:ext cx="2560320" cy="1325880"/>
-          </a:xfrm>
-          <a:prstGeom prst="roundRect">
-            <a:avLst/>
-          </a:prstGeom>
-          <a:solidFill>
-            <a:srgbClr val="F5F7F9"/>
-          </a:solidFill>
-          <a:ln w="12700">
-            <a:solidFill>
-              <a:srgbClr val="D9DFE5"/>
-            </a:solidFill>
-          </a:ln>
-        </p:spPr>
-        <p:style>
-          <a:lnRef idx="1">
-            <a:schemeClr val="accent1"/>
-          </a:lnRef>
-          <a:fillRef idx="3">
-            <a:schemeClr val="accent1"/>
-          </a:fillRef>
-          <a:effectRef idx="2">
-            <a:schemeClr val="accent1"/>
-          </a:effectRef>
-          <a:fontRef idx="minor">
-            <a:schemeClr val="lt1"/>
-          </a:fontRef>
-        </p:style>
-        <p:txBody>
-          <a:bodyPr rtlCol="0" anchor="ctr"/>
-          <a:lstStyle/>
-          <a:p>
-            <a:pPr algn="ctr"/>
-          </a:p>
-        </p:txBody>
-      </p:sp>
-      <p:sp>
-        <p:nvSpPr>
-          <p:cNvPr id="14" name="TextBox 13"/>
-          <p:cNvSpPr txBox="1"/>
-          <p:nvPr/>
-        </p:nvSpPr>
-        <p:spPr>
-          <a:xfrm>
-            <a:off x="6400800" y="1389888"/>
-            <a:ext cx="2286000" cy="274320"/>
-          </a:xfrm>
-          <a:prstGeom prst="rect">
-            <a:avLst/>
-          </a:prstGeom>
-          <a:noFill/>
-        </p:spPr>
-        <p:txBody>
-          <a:bodyPr wrap="square" anchor="ctr">
-            <a:spAutoFit/>
-          </a:bodyPr>
-          <a:lstStyle/>
-          <a:p>
-            <a:pPr algn="l"/>
-            <a:r>
-              <a:rPr sz="1100" b="0">
-                <a:solidFill>
-                  <a:srgbClr val="6B7785"/>
-                </a:solidFill>
-                <a:latin typeface="Aptos"/>
-              </a:rPr>
-              <a:t>Disponibilidad</a:t>
-            </a:r>
-          </a:p>
-        </p:txBody>
-      </p:sp>
-      <p:sp>
-        <p:nvSpPr>
-          <p:cNvPr id="15" name="TextBox 14"/>
-          <p:cNvSpPr txBox="1"/>
-          <p:nvPr/>
-        </p:nvSpPr>
-        <p:spPr>
-          <a:xfrm>
-            <a:off x="6400800" y="1719072"/>
-            <a:ext cx="2286000" cy="502920"/>
-          </a:xfrm>
-          <a:prstGeom prst="rect">
-            <a:avLst/>
-          </a:prstGeom>
-          <a:noFill/>
-        </p:spPr>
-        <p:txBody>
-          <a:bodyPr wrap="square" anchor="ctr">
-            <a:spAutoFit/>
-          </a:bodyPr>
-          <a:lstStyle/>
-          <a:p>
-            <a:pPr algn="l"/>
-            <a:r>
-              <a:rPr sz="1900" b="1">
-                <a:solidFill>
-                  <a:srgbClr val="1B2533"/>
-                </a:solidFill>
-                <a:latin typeface="Aptos"/>
-              </a:rPr>
-              <a:t>96.8 %</a:t>
-            </a:r>
-          </a:p>
-        </p:txBody>
-      </p:sp>
-      <p:sp>
-        <p:nvSpPr>
-          <p:cNvPr id="16" name="Rounded Rectangle 15"/>
-          <p:cNvSpPr/>
-          <p:nvPr/>
-        </p:nvSpPr>
-        <p:spPr>
-          <a:xfrm>
-            <a:off x="9052559" y="1234440"/>
-            <a:ext cx="2560320" cy="1325880"/>
-          </a:xfrm>
-          <a:prstGeom prst="roundRect">
-            <a:avLst/>
-          </a:prstGeom>
-          <a:solidFill>
-            <a:srgbClr val="F5F7F9"/>
-          </a:solidFill>
-          <a:ln w="12700">
-            <a:solidFill>
-              <a:srgbClr val="D9DFE5"/>
-            </a:solidFill>
-          </a:ln>
-        </p:spPr>
-        <p:style>
-          <a:lnRef idx="1">
-            <a:schemeClr val="accent1"/>
-          </a:lnRef>
-          <a:fillRef idx="3">
-            <a:schemeClr val="accent1"/>
-          </a:fillRef>
-          <a:effectRef idx="2">
-            <a:schemeClr val="accent1"/>
-          </a:effectRef>
-          <a:fontRef idx="minor">
-            <a:schemeClr val="lt1"/>
-          </a:fontRef>
-        </p:style>
-        <p:txBody>
-          <a:bodyPr rtlCol="0" anchor="ctr"/>
-          <a:lstStyle/>
-          <a:p>
-            <a:pPr algn="ctr"/>
-          </a:p>
-        </p:txBody>
-      </p:sp>
-      <p:sp>
-        <p:nvSpPr>
-          <p:cNvPr id="17" name="TextBox 16"/>
-          <p:cNvSpPr txBox="1"/>
-          <p:nvPr/>
-        </p:nvSpPr>
-        <p:spPr>
-          <a:xfrm>
-            <a:off x="9189719" y="1389888"/>
-            <a:ext cx="2286000" cy="274320"/>
-          </a:xfrm>
-          <a:prstGeom prst="rect">
-            <a:avLst/>
-          </a:prstGeom>
-          <a:noFill/>
-        </p:spPr>
-        <p:txBody>
-          <a:bodyPr wrap="square" anchor="ctr">
-            <a:spAutoFit/>
-          </a:bodyPr>
-          <a:lstStyle/>
-          <a:p>
-            <a:pPr algn="l"/>
-            <a:r>
-              <a:rPr sz="1100" b="0">
-                <a:solidFill>
-                  <a:srgbClr val="6B7785"/>
-                </a:solidFill>
-                <a:latin typeface="Aptos"/>
-              </a:rPr>
-              <a:t>CO2 evitado</a:t>
-            </a:r>
-          </a:p>
-        </p:txBody>
-      </p:sp>
-      <p:sp>
-        <p:nvSpPr>
-          <p:cNvPr id="18" name="TextBox 17"/>
-          <p:cNvSpPr txBox="1"/>
-          <p:nvPr/>
-        </p:nvSpPr>
-        <p:spPr>
-          <a:xfrm>
-            <a:off x="9189719" y="1719072"/>
-            <a:ext cx="2286000" cy="502920"/>
-          </a:xfrm>
-          <a:prstGeom prst="rect">
-            <a:avLst/>
-          </a:prstGeom>
-          <a:noFill/>
-        </p:spPr>
-        <p:txBody>
-          <a:bodyPr wrap="square" anchor="ctr">
-            <a:spAutoFit/>
-          </a:bodyPr>
-          <a:lstStyle/>
-          <a:p>
-            <a:pPr algn="l"/>
-            <a:r>
-              <a:rPr sz="1900" b="1">
-                <a:solidFill>
-                  <a:srgbClr val="00A972"/>
-                </a:solidFill>
-                <a:latin typeface="Aptos"/>
-              </a:rPr>
-              <a:t>1254.3 kt</a:t>
-            </a:r>
-          </a:p>
-        </p:txBody>
-      </p:sp>
-      <p:sp>
-        <p:nvSpPr>
-          <p:cNvPr id="19" name="TextBox 18"/>
-          <p:cNvSpPr txBox="1"/>
-          <p:nvPr/>
-        </p:nvSpPr>
-        <p:spPr>
-          <a:xfrm>
-            <a:off x="868680" y="2953512"/>
-            <a:ext cx="3657600" cy="274320"/>
-          </a:xfrm>
-          <a:prstGeom prst="rect">
-            <a:avLst/>
-          </a:prstGeom>
-          <a:noFill/>
-        </p:spPr>
-        <p:txBody>
-          <a:bodyPr wrap="square" anchor="ctr">
-            <a:spAutoFit/>
-          </a:bodyPr>
-          <a:lstStyle/>
-          <a:p>
-            <a:pPr algn="l"/>
-            <a:r>
-              <a:rPr sz="1300" b="1">
-                <a:solidFill>
-                  <a:srgbClr val="1B2533"/>
-                </a:solidFill>
-                <a:latin typeface="Aptos"/>
-              </a:rPr>
-              <a:t>Real frente a prevista</a:t>
-            </a:r>
-          </a:p>
-        </p:txBody>
-      </p:sp>
-      <p:cxnSp>
-        <p:nvCxnSpPr>
-          <p:cNvPr id="20" name="Connector 19"/>
-          <p:cNvCxnSpPr/>
-          <p:nvPr/>
-        </p:nvCxnSpPr>
-        <p:spPr>
-          <a:xfrm>
-            <a:off x="868680" y="5641848"/>
-            <a:ext cx="6766560" cy="0"/>
-          </a:xfrm>
-          <a:prstGeom prst="line">
-            <a:avLst/>
-          </a:prstGeom>
-          <a:ln>
-            <a:solidFill>
-              <a:srgbClr val="D9DFE5"/>
-            </a:solidFill>
-          </a:ln>
-        </p:spPr>
-        <p:style>
-          <a:lnRef idx="2">
-            <a:schemeClr val="accent1"/>
-          </a:lnRef>
-          <a:fillRef idx="0">
-            <a:schemeClr val="accent1"/>
-          </a:fillRef>
-          <a:effectRef idx="1">
-            <a:schemeClr val="accent1"/>
-          </a:effectRef>
-          <a:fontRef idx="minor">
-            <a:schemeClr val="tx1"/>
-          </a:fontRef>
-        </p:style>
-      </p:cxnSp>
-      <p:cxnSp>
-        <p:nvCxnSpPr>
-          <p:cNvPr id="21" name="Connector 20"/>
-          <p:cNvCxnSpPr/>
-          <p:nvPr/>
-        </p:nvCxnSpPr>
-        <p:spPr>
-          <a:xfrm>
-            <a:off x="868680" y="4670545"/>
-            <a:ext cx="398032" cy="570440"/>
-          </a:xfrm>
-          <a:prstGeom prst="line">
-            <a:avLst/>
-          </a:prstGeom>
-          <a:ln w="25400">
-            <a:solidFill>
-              <a:srgbClr val="00A972"/>
-            </a:solidFill>
-          </a:ln>
-        </p:spPr>
-        <p:style>
-          <a:lnRef idx="2">
-            <a:schemeClr val="accent1"/>
-          </a:lnRef>
-          <a:fillRef idx="0">
-            <a:schemeClr val="accent1"/>
-          </a:fillRef>
-          <a:effectRef idx="1">
-            <a:schemeClr val="accent1"/>
-          </a:effectRef>
-          <a:fontRef idx="minor">
-            <a:schemeClr val="tx1"/>
-          </a:fontRef>
-        </p:style>
-      </p:cxnSp>
-      <p:cxnSp>
-        <p:nvCxnSpPr>
-          <p:cNvPr id="22" name="Connector 21"/>
-          <p:cNvCxnSpPr/>
-          <p:nvPr/>
-        </p:nvCxnSpPr>
-        <p:spPr>
-          <a:xfrm flipV="1">
-            <a:off x="1266712" y="4361825"/>
-            <a:ext cx="398033" cy="879160"/>
-          </a:xfrm>
-          <a:prstGeom prst="line">
-            <a:avLst/>
-          </a:prstGeom>
-          <a:ln w="25400">
-            <a:solidFill>
-              <a:srgbClr val="00A972"/>
-            </a:solidFill>
-          </a:ln>
-        </p:spPr>
-        <p:style>
-          <a:lnRef idx="2">
-            <a:schemeClr val="accent1"/>
-          </a:lnRef>
-          <a:fillRef idx="0">
-            <a:schemeClr val="accent1"/>
-          </a:fillRef>
-          <a:effectRef idx="1">
-            <a:schemeClr val="accent1"/>
-          </a:effectRef>
-          <a:fontRef idx="minor">
-            <a:schemeClr val="tx1"/>
-          </a:fontRef>
-        </p:style>
-      </p:cxnSp>
-      <p:cxnSp>
-        <p:nvCxnSpPr>
-          <p:cNvPr id="23" name="Connector 22"/>
-          <p:cNvCxnSpPr/>
-          <p:nvPr/>
-        </p:nvCxnSpPr>
-        <p:spPr>
-          <a:xfrm flipV="1">
-            <a:off x="1664745" y="4028978"/>
-            <a:ext cx="398033" cy="332847"/>
-          </a:xfrm>
-          <a:prstGeom prst="line">
-            <a:avLst/>
-          </a:prstGeom>
-          <a:ln w="25400">
-            <a:solidFill>
-              <a:srgbClr val="00A972"/>
-            </a:solidFill>
-          </a:ln>
-        </p:spPr>
-        <p:style>
-          <a:lnRef idx="2">
-            <a:schemeClr val="accent1"/>
-          </a:lnRef>
-          <a:fillRef idx="0">
-            <a:schemeClr val="accent1"/>
-          </a:fillRef>
-          <a:effectRef idx="1">
-            <a:schemeClr val="accent1"/>
-          </a:effectRef>
-          <a:fontRef idx="minor">
-            <a:schemeClr val="tx1"/>
-          </a:fontRef>
-        </p:style>
-      </p:cxnSp>
-      <p:cxnSp>
-        <p:nvCxnSpPr>
-          <p:cNvPr id="24" name="Connector 23"/>
-          <p:cNvCxnSpPr/>
-          <p:nvPr/>
-        </p:nvCxnSpPr>
-        <p:spPr>
-          <a:xfrm flipV="1">
-            <a:off x="2062778" y="3584250"/>
-            <a:ext cx="398033" cy="444728"/>
-          </a:xfrm>
-          <a:prstGeom prst="line">
-            <a:avLst/>
-          </a:prstGeom>
-          <a:ln w="25400">
-            <a:solidFill>
-              <a:srgbClr val="00A972"/>
-            </a:solidFill>
-          </a:ln>
-        </p:spPr>
-        <p:style>
-          <a:lnRef idx="2">
-            <a:schemeClr val="accent1"/>
-          </a:lnRef>
-          <a:fillRef idx="0">
-            <a:schemeClr val="accent1"/>
-          </a:fillRef>
-          <a:effectRef idx="1">
-            <a:schemeClr val="accent1"/>
-          </a:effectRef>
-          <a:fontRef idx="minor">
-            <a:schemeClr val="tx1"/>
-          </a:fontRef>
-        </p:style>
-      </p:cxnSp>
-      <p:cxnSp>
-        <p:nvCxnSpPr>
-          <p:cNvPr id="25" name="Connector 24"/>
-          <p:cNvCxnSpPr/>
-          <p:nvPr/>
-        </p:nvCxnSpPr>
-        <p:spPr>
-          <a:xfrm>
-            <a:off x="2460811" y="3584250"/>
-            <a:ext cx="398033" cy="393155"/>
-          </a:xfrm>
-          <a:prstGeom prst="line">
-            <a:avLst/>
-          </a:prstGeom>
-          <a:ln w="25400">
-            <a:solidFill>
-              <a:srgbClr val="00A972"/>
-            </a:solidFill>
-          </a:ln>
-        </p:spPr>
-        <p:style>
-          <a:lnRef idx="2">
-            <a:schemeClr val="accent1"/>
-          </a:lnRef>
-          <a:fillRef idx="0">
-            <a:schemeClr val="accent1"/>
-          </a:fillRef>
-          <a:effectRef idx="1">
-            <a:schemeClr val="accent1"/>
-          </a:effectRef>
-          <a:fontRef idx="minor">
-            <a:schemeClr val="tx1"/>
-          </a:fontRef>
-        </p:style>
-      </p:cxnSp>
-      <p:cxnSp>
-        <p:nvCxnSpPr>
-          <p:cNvPr id="26" name="Connector 25"/>
-          <p:cNvCxnSpPr/>
-          <p:nvPr/>
-        </p:nvCxnSpPr>
-        <p:spPr>
-          <a:xfrm>
-            <a:off x="2858844" y="3977405"/>
-            <a:ext cx="398033" cy="279593"/>
-          </a:xfrm>
-          <a:prstGeom prst="line">
-            <a:avLst/>
-          </a:prstGeom>
-          <a:ln w="25400">
-            <a:solidFill>
-              <a:srgbClr val="00A972"/>
-            </a:solidFill>
-          </a:ln>
-        </p:spPr>
-        <p:style>
-          <a:lnRef idx="2">
-            <a:schemeClr val="accent1"/>
-          </a:lnRef>
-          <a:fillRef idx="0">
-            <a:schemeClr val="accent1"/>
-          </a:fillRef>
-          <a:effectRef idx="1">
-            <a:schemeClr val="accent1"/>
-          </a:effectRef>
-          <a:fontRef idx="minor">
-            <a:schemeClr val="tx1"/>
-          </a:fontRef>
-        </p:style>
-      </p:cxnSp>
-      <p:cxnSp>
-        <p:nvCxnSpPr>
-          <p:cNvPr id="27" name="Connector 26"/>
-          <p:cNvCxnSpPr/>
-          <p:nvPr/>
-        </p:nvCxnSpPr>
-        <p:spPr>
-          <a:xfrm>
-            <a:off x="3256877" y="4256998"/>
-            <a:ext cx="398033" cy="381174"/>
-          </a:xfrm>
-          <a:prstGeom prst="line">
-            <a:avLst/>
-          </a:prstGeom>
-          <a:ln w="25400">
-            <a:solidFill>
-              <a:srgbClr val="00A972"/>
-            </a:solidFill>
-          </a:ln>
-        </p:spPr>
-        <p:style>
-          <a:lnRef idx="2">
-            <a:schemeClr val="accent1"/>
-          </a:lnRef>
-          <a:fillRef idx="0">
-            <a:schemeClr val="accent1"/>
-          </a:fillRef>
-          <a:effectRef idx="1">
-            <a:schemeClr val="accent1"/>
-          </a:effectRef>
-          <a:fontRef idx="minor">
-            <a:schemeClr val="tx1"/>
-          </a:fontRef>
-        </p:style>
-      </p:cxnSp>
-      <p:cxnSp>
-        <p:nvCxnSpPr>
-          <p:cNvPr id="28" name="Connector 27"/>
-          <p:cNvCxnSpPr/>
-          <p:nvPr/>
-        </p:nvCxnSpPr>
-        <p:spPr>
-          <a:xfrm>
-            <a:off x="3654910" y="4638172"/>
-            <a:ext cx="398033" cy="238724"/>
-          </a:xfrm>
-          <a:prstGeom prst="line">
-            <a:avLst/>
-          </a:prstGeom>
-          <a:ln w="25400">
-            <a:solidFill>
-              <a:srgbClr val="00A972"/>
-            </a:solidFill>
-          </a:ln>
-        </p:spPr>
-        <p:style>
-          <a:lnRef idx="2">
-            <a:schemeClr val="accent1"/>
-          </a:lnRef>
-          <a:fillRef idx="0">
-            <a:schemeClr val="accent1"/>
-          </a:fillRef>
-          <a:effectRef idx="1">
-            <a:schemeClr val="accent1"/>
-          </a:effectRef>
-          <a:fontRef idx="minor">
-            <a:schemeClr val="tx1"/>
-          </a:fontRef>
-        </p:style>
-      </p:cxnSp>
-      <p:cxnSp>
-        <p:nvCxnSpPr>
-          <p:cNvPr id="29" name="Connector 28"/>
-          <p:cNvCxnSpPr/>
-          <p:nvPr/>
-        </p:nvCxnSpPr>
-        <p:spPr>
-          <a:xfrm flipV="1">
-            <a:off x="4052943" y="4349864"/>
-            <a:ext cx="398033" cy="527032"/>
-          </a:xfrm>
-          <a:prstGeom prst="line">
-            <a:avLst/>
-          </a:prstGeom>
-          <a:ln w="25400">
-            <a:solidFill>
-              <a:srgbClr val="00A972"/>
-            </a:solidFill>
-          </a:ln>
-        </p:spPr>
-        <p:style>
-          <a:lnRef idx="2">
-            <a:schemeClr val="accent1"/>
-          </a:lnRef>
-          <a:fillRef idx="0">
-            <a:schemeClr val="accent1"/>
-          </a:fillRef>
-          <a:effectRef idx="1">
-            <a:schemeClr val="accent1"/>
-          </a:effectRef>
-          <a:fontRef idx="minor">
-            <a:schemeClr val="tx1"/>
-          </a:fontRef>
-        </p:style>
-      </p:cxnSp>
-      <p:cxnSp>
-        <p:nvCxnSpPr>
-          <p:cNvPr id="30" name="Connector 29"/>
-          <p:cNvCxnSpPr/>
-          <p:nvPr/>
-        </p:nvCxnSpPr>
-        <p:spPr>
-          <a:xfrm>
-            <a:off x="4450976" y="4349864"/>
-            <a:ext cx="398033" cy="1291984"/>
-          </a:xfrm>
-          <a:prstGeom prst="line">
-            <a:avLst/>
-          </a:prstGeom>
-          <a:ln w="25400">
-            <a:solidFill>
-              <a:srgbClr val="00A972"/>
-            </a:solidFill>
-          </a:ln>
-        </p:spPr>
-        <p:style>
-          <a:lnRef idx="2">
-            <a:schemeClr val="accent1"/>
-          </a:lnRef>
-          <a:fillRef idx="0">
-            <a:schemeClr val="accent1"/>
-          </a:fillRef>
-          <a:effectRef idx="1">
-            <a:schemeClr val="accent1"/>
-          </a:effectRef>
-          <a:fontRef idx="minor">
-            <a:schemeClr val="tx1"/>
-          </a:fontRef>
-        </p:style>
-      </p:cxnSp>
-      <p:cxnSp>
-        <p:nvCxnSpPr>
-          <p:cNvPr id="31" name="Connector 30"/>
-          <p:cNvCxnSpPr/>
-          <p:nvPr/>
-        </p:nvCxnSpPr>
-        <p:spPr>
-          <a:xfrm flipV="1">
-            <a:off x="4849009" y="4368914"/>
-            <a:ext cx="398033" cy="1272934"/>
-          </a:xfrm>
-          <a:prstGeom prst="line">
-            <a:avLst/>
-          </a:prstGeom>
-          <a:ln w="25400">
-            <a:solidFill>
-              <a:srgbClr val="00A972"/>
-            </a:solidFill>
-          </a:ln>
-        </p:spPr>
-        <p:style>
-          <a:lnRef idx="2">
-            <a:schemeClr val="accent1"/>
-          </a:lnRef>
-          <a:fillRef idx="0">
-            <a:schemeClr val="accent1"/>
-          </a:fillRef>
-          <a:effectRef idx="1">
-            <a:schemeClr val="accent1"/>
-          </a:effectRef>
-          <a:fontRef idx="minor">
-            <a:schemeClr val="tx1"/>
-          </a:fontRef>
-        </p:style>
-      </p:cxnSp>
-      <p:cxnSp>
-        <p:nvCxnSpPr>
-          <p:cNvPr id="32" name="Connector 31"/>
-          <p:cNvCxnSpPr/>
-          <p:nvPr/>
-        </p:nvCxnSpPr>
-        <p:spPr>
-          <a:xfrm>
-            <a:off x="5247042" y="4368914"/>
-            <a:ext cx="398033" cy="276646"/>
-          </a:xfrm>
-          <a:prstGeom prst="line">
-            <a:avLst/>
-          </a:prstGeom>
-          <a:ln w="25400">
-            <a:solidFill>
-              <a:srgbClr val="00A972"/>
-            </a:solidFill>
-          </a:ln>
-        </p:spPr>
-        <p:style>
-          <a:lnRef idx="2">
-            <a:schemeClr val="accent1"/>
-          </a:lnRef>
-          <a:fillRef idx="0">
-            <a:schemeClr val="accent1"/>
-          </a:fillRef>
-          <a:effectRef idx="1">
-            <a:schemeClr val="accent1"/>
-          </a:effectRef>
-          <a:fontRef idx="minor">
-            <a:schemeClr val="tx1"/>
-          </a:fontRef>
-        </p:style>
-      </p:cxnSp>
-      <p:cxnSp>
-        <p:nvCxnSpPr>
-          <p:cNvPr id="33" name="Connector 32"/>
-          <p:cNvCxnSpPr/>
-          <p:nvPr/>
-        </p:nvCxnSpPr>
-        <p:spPr>
-          <a:xfrm>
-            <a:off x="5645075" y="4645560"/>
-            <a:ext cx="398033" cy="606310"/>
-          </a:xfrm>
-          <a:prstGeom prst="line">
-            <a:avLst/>
-          </a:prstGeom>
-          <a:ln w="25400">
-            <a:solidFill>
-              <a:srgbClr val="00A972"/>
-            </a:solidFill>
-          </a:ln>
-        </p:spPr>
-        <p:style>
-          <a:lnRef idx="2">
-            <a:schemeClr val="accent1"/>
-          </a:lnRef>
-          <a:fillRef idx="0">
-            <a:schemeClr val="accent1"/>
-          </a:fillRef>
-          <a:effectRef idx="1">
-            <a:schemeClr val="accent1"/>
-          </a:effectRef>
-          <a:fontRef idx="minor">
-            <a:schemeClr val="tx1"/>
-          </a:fontRef>
-        </p:style>
-      </p:cxnSp>
-      <p:cxnSp>
-        <p:nvCxnSpPr>
-          <p:cNvPr id="34" name="Connector 33"/>
-          <p:cNvCxnSpPr/>
-          <p:nvPr/>
-        </p:nvCxnSpPr>
-        <p:spPr>
-          <a:xfrm flipV="1">
-            <a:off x="6043108" y="4380241"/>
-            <a:ext cx="398033" cy="871629"/>
-          </a:xfrm>
-          <a:prstGeom prst="line">
-            <a:avLst/>
-          </a:prstGeom>
-          <a:ln w="25400">
-            <a:solidFill>
-              <a:srgbClr val="00A972"/>
-            </a:solidFill>
-          </a:ln>
-        </p:spPr>
-        <p:style>
-          <a:lnRef idx="2">
-            <a:schemeClr val="accent1"/>
-          </a:lnRef>
-          <a:fillRef idx="0">
-            <a:schemeClr val="accent1"/>
-          </a:fillRef>
-          <a:effectRef idx="1">
-            <a:schemeClr val="accent1"/>
-          </a:effectRef>
-          <a:fontRef idx="minor">
-            <a:schemeClr val="tx1"/>
-          </a:fontRef>
-        </p:style>
-      </p:cxnSp>
-      <p:cxnSp>
-        <p:nvCxnSpPr>
-          <p:cNvPr id="35" name="Connector 34"/>
-          <p:cNvCxnSpPr/>
-          <p:nvPr/>
-        </p:nvCxnSpPr>
-        <p:spPr>
-          <a:xfrm flipV="1">
-            <a:off x="6441141" y="4032795"/>
-            <a:ext cx="398033" cy="347446"/>
-          </a:xfrm>
-          <a:prstGeom prst="line">
-            <a:avLst/>
-          </a:prstGeom>
-          <a:ln w="25400">
-            <a:solidFill>
-              <a:srgbClr val="00A972"/>
-            </a:solidFill>
-          </a:ln>
-        </p:spPr>
-        <p:style>
-          <a:lnRef idx="2">
-            <a:schemeClr val="accent1"/>
-          </a:lnRef>
-          <a:fillRef idx="0">
-            <a:schemeClr val="accent1"/>
-          </a:fillRef>
-          <a:effectRef idx="1">
-            <a:schemeClr val="accent1"/>
-          </a:effectRef>
-          <a:fontRef idx="minor">
-            <a:schemeClr val="tx1"/>
-          </a:fontRef>
-        </p:style>
-      </p:cxnSp>
-      <p:cxnSp>
-        <p:nvCxnSpPr>
-          <p:cNvPr id="36" name="Connector 35"/>
-          <p:cNvCxnSpPr/>
-          <p:nvPr/>
-        </p:nvCxnSpPr>
-        <p:spPr>
-          <a:xfrm flipV="1">
-            <a:off x="6839174" y="3558024"/>
-            <a:ext cx="398033" cy="474771"/>
-          </a:xfrm>
-          <a:prstGeom prst="line">
-            <a:avLst/>
-          </a:prstGeom>
-          <a:ln w="25400">
-            <a:solidFill>
-              <a:srgbClr val="00A972"/>
-            </a:solidFill>
-          </a:ln>
-        </p:spPr>
-        <p:style>
-          <a:lnRef idx="2">
-            <a:schemeClr val="accent1"/>
-          </a:lnRef>
-          <a:fillRef idx="0">
-            <a:schemeClr val="accent1"/>
-          </a:fillRef>
-          <a:effectRef idx="1">
-            <a:schemeClr val="accent1"/>
-          </a:effectRef>
-          <a:fontRef idx="minor">
-            <a:schemeClr val="tx1"/>
-          </a:fontRef>
-        </p:style>
-      </p:cxnSp>
-      <p:cxnSp>
-        <p:nvCxnSpPr>
-          <p:cNvPr id="37" name="Connector 36"/>
-          <p:cNvCxnSpPr/>
-          <p:nvPr/>
-        </p:nvCxnSpPr>
-        <p:spPr>
-          <a:xfrm>
-            <a:off x="7237207" y="3558024"/>
-            <a:ext cx="398033" cy="410028"/>
-          </a:xfrm>
-          <a:prstGeom prst="line">
-            <a:avLst/>
-          </a:prstGeom>
-          <a:ln w="25400">
-            <a:solidFill>
-              <a:srgbClr val="00A972"/>
-            </a:solidFill>
-          </a:ln>
-        </p:spPr>
-        <p:style>
-          <a:lnRef idx="2">
-            <a:schemeClr val="accent1"/>
-          </a:lnRef>
-          <a:fillRef idx="0">
-            <a:schemeClr val="accent1"/>
-          </a:fillRef>
-          <a:effectRef idx="1">
-            <a:schemeClr val="accent1"/>
-          </a:effectRef>
-          <a:fontRef idx="minor">
-            <a:schemeClr val="tx1"/>
-          </a:fontRef>
-        </p:style>
-      </p:cxnSp>
-      <p:cxnSp>
-        <p:nvCxnSpPr>
-          <p:cNvPr id="38" name="Connector 37"/>
-          <p:cNvCxnSpPr/>
-          <p:nvPr/>
-        </p:nvCxnSpPr>
-        <p:spPr>
-          <a:xfrm>
-            <a:off x="868680" y="4646970"/>
-            <a:ext cx="398032" cy="581275"/>
-          </a:xfrm>
-          <a:prstGeom prst="line">
-            <a:avLst/>
-          </a:prstGeom>
-          <a:ln w="25400">
-            <a:solidFill>
-              <a:srgbClr val="1B2533"/>
-            </a:solidFill>
-          </a:ln>
-        </p:spPr>
-        <p:style>
-          <a:lnRef idx="2">
-            <a:schemeClr val="accent1"/>
-          </a:lnRef>
-          <a:fillRef idx="0">
-            <a:schemeClr val="accent1"/>
-          </a:fillRef>
-          <a:effectRef idx="1">
-            <a:schemeClr val="accent1"/>
-          </a:effectRef>
-          <a:fontRef idx="minor">
-            <a:schemeClr val="tx1"/>
-          </a:fontRef>
-        </p:style>
-      </p:cxnSp>
-      <p:cxnSp>
-        <p:nvCxnSpPr>
-          <p:cNvPr id="39" name="Connector 38"/>
-          <p:cNvCxnSpPr/>
-          <p:nvPr/>
-        </p:nvCxnSpPr>
-        <p:spPr>
-          <a:xfrm flipV="1">
-            <a:off x="1266712" y="4346401"/>
-            <a:ext cx="398033" cy="881844"/>
-          </a:xfrm>
-          <a:prstGeom prst="line">
-            <a:avLst/>
-          </a:prstGeom>
-          <a:ln w="25400">
-            <a:solidFill>
-              <a:srgbClr val="1B2533"/>
-            </a:solidFill>
-          </a:ln>
-        </p:spPr>
-        <p:style>
-          <a:lnRef idx="2">
-            <a:schemeClr val="accent1"/>
-          </a:lnRef>
-          <a:fillRef idx="0">
-            <a:schemeClr val="accent1"/>
-          </a:fillRef>
-          <a:effectRef idx="1">
-            <a:schemeClr val="accent1"/>
-          </a:effectRef>
-          <a:fontRef idx="minor">
-            <a:schemeClr val="tx1"/>
-          </a:fontRef>
-        </p:style>
-      </p:cxnSp>
-      <p:cxnSp>
-        <p:nvCxnSpPr>
-          <p:cNvPr id="40" name="Connector 39"/>
-          <p:cNvCxnSpPr/>
-          <p:nvPr/>
-        </p:nvCxnSpPr>
-        <p:spPr>
-          <a:xfrm flipV="1">
-            <a:off x="1664745" y="4023157"/>
-            <a:ext cx="398033" cy="323244"/>
-          </a:xfrm>
-          <a:prstGeom prst="line">
-            <a:avLst/>
-          </a:prstGeom>
-          <a:ln w="25400">
-            <a:solidFill>
-              <a:srgbClr val="1B2533"/>
-            </a:solidFill>
-          </a:ln>
-        </p:spPr>
-        <p:style>
-          <a:lnRef idx="2">
-            <a:schemeClr val="accent1"/>
-          </a:lnRef>
-          <a:fillRef idx="0">
-            <a:schemeClr val="accent1"/>
-          </a:fillRef>
-          <a:effectRef idx="1">
-            <a:schemeClr val="accent1"/>
-          </a:effectRef>
-          <a:fontRef idx="minor">
-            <a:schemeClr val="tx1"/>
-          </a:fontRef>
-        </p:style>
-      </p:cxnSp>
-      <p:cxnSp>
-        <p:nvCxnSpPr>
-          <p:cNvPr id="41" name="Connector 40"/>
-          <p:cNvCxnSpPr/>
-          <p:nvPr/>
-        </p:nvCxnSpPr>
-        <p:spPr>
-          <a:xfrm flipV="1">
-            <a:off x="2062778" y="3547189"/>
-            <a:ext cx="398033" cy="475968"/>
-          </a:xfrm>
-          <a:prstGeom prst="line">
-            <a:avLst/>
-          </a:prstGeom>
-          <a:ln w="25400">
-            <a:solidFill>
-              <a:srgbClr val="1B2533"/>
-            </a:solidFill>
-          </a:ln>
-        </p:spPr>
-        <p:style>
-          <a:lnRef idx="2">
-            <a:schemeClr val="accent1"/>
-          </a:lnRef>
-          <a:fillRef idx="0">
-            <a:schemeClr val="accent1"/>
-          </a:fillRef>
-          <a:effectRef idx="1">
-            <a:schemeClr val="accent1"/>
-          </a:effectRef>
-          <a:fontRef idx="minor">
-            <a:schemeClr val="tx1"/>
-          </a:fontRef>
-        </p:style>
-      </p:cxnSp>
-      <p:cxnSp>
-        <p:nvCxnSpPr>
-          <p:cNvPr id="42" name="Connector 41"/>
-          <p:cNvCxnSpPr/>
-          <p:nvPr/>
-        </p:nvCxnSpPr>
-        <p:spPr>
-          <a:xfrm>
-            <a:off x="2460811" y="3547189"/>
-            <a:ext cx="398033" cy="401219"/>
-          </a:xfrm>
-          <a:prstGeom prst="line">
-            <a:avLst/>
-          </a:prstGeom>
-          <a:ln w="25400">
-            <a:solidFill>
-              <a:srgbClr val="1B2533"/>
-            </a:solidFill>
-          </a:ln>
-        </p:spPr>
-        <p:style>
-          <a:lnRef idx="2">
-            <a:schemeClr val="accent1"/>
-          </a:lnRef>
-          <a:fillRef idx="0">
-            <a:schemeClr val="accent1"/>
-          </a:fillRef>
-          <a:effectRef idx="1">
-            <a:schemeClr val="accent1"/>
-          </a:effectRef>
-          <a:fontRef idx="minor">
-            <a:schemeClr val="tx1"/>
-          </a:fontRef>
-        </p:style>
-      </p:cxnSp>
-      <p:cxnSp>
-        <p:nvCxnSpPr>
-          <p:cNvPr id="43" name="Connector 42"/>
-          <p:cNvCxnSpPr/>
-          <p:nvPr/>
-        </p:nvCxnSpPr>
-        <p:spPr>
-          <a:xfrm>
-            <a:off x="2858844" y="3948408"/>
-            <a:ext cx="398033" cy="283332"/>
-          </a:xfrm>
-          <a:prstGeom prst="line">
-            <a:avLst/>
-          </a:prstGeom>
-          <a:ln w="25400">
-            <a:solidFill>
-              <a:srgbClr val="1B2533"/>
-            </a:solidFill>
-          </a:ln>
-        </p:spPr>
-        <p:style>
-          <a:lnRef idx="2">
-            <a:schemeClr val="accent1"/>
-          </a:lnRef>
-          <a:fillRef idx="0">
-            <a:schemeClr val="accent1"/>
-          </a:fillRef>
-          <a:effectRef idx="1">
-            <a:schemeClr val="accent1"/>
-          </a:effectRef>
-          <a:fontRef idx="minor">
-            <a:schemeClr val="tx1"/>
-          </a:fontRef>
-        </p:style>
-      </p:cxnSp>
-      <p:cxnSp>
-        <p:nvCxnSpPr>
-          <p:cNvPr id="44" name="Connector 43"/>
-          <p:cNvCxnSpPr/>
-          <p:nvPr/>
-        </p:nvCxnSpPr>
-        <p:spPr>
-          <a:xfrm>
-            <a:off x="3256877" y="4231740"/>
-            <a:ext cx="398033" cy="393609"/>
-          </a:xfrm>
-          <a:prstGeom prst="line">
-            <a:avLst/>
-          </a:prstGeom>
-          <a:ln w="25400">
-            <a:solidFill>
-              <a:srgbClr val="1B2533"/>
-            </a:solidFill>
-          </a:ln>
-        </p:spPr>
-        <p:style>
-          <a:lnRef idx="2">
-            <a:schemeClr val="accent1"/>
-          </a:lnRef>
-          <a:fillRef idx="0">
-            <a:schemeClr val="accent1"/>
-          </a:fillRef>
-          <a:effectRef idx="1">
-            <a:schemeClr val="accent1"/>
-          </a:effectRef>
-          <a:fontRef idx="minor">
-            <a:schemeClr val="tx1"/>
-          </a:fontRef>
-        </p:style>
-      </p:cxnSp>
-      <p:cxnSp>
-        <p:nvCxnSpPr>
-          <p:cNvPr id="45" name="Connector 44"/>
-          <p:cNvCxnSpPr/>
-          <p:nvPr/>
-        </p:nvCxnSpPr>
-        <p:spPr>
-          <a:xfrm>
-            <a:off x="3654910" y="4625349"/>
-            <a:ext cx="398033" cy="171383"/>
-          </a:xfrm>
-          <a:prstGeom prst="line">
-            <a:avLst/>
-          </a:prstGeom>
-          <a:ln w="25400">
-            <a:solidFill>
-              <a:srgbClr val="1B2533"/>
-            </a:solidFill>
-          </a:ln>
-        </p:spPr>
-        <p:style>
-          <a:lnRef idx="2">
-            <a:schemeClr val="accent1"/>
-          </a:lnRef>
-          <a:fillRef idx="0">
-            <a:schemeClr val="accent1"/>
-          </a:fillRef>
-          <a:effectRef idx="1">
-            <a:schemeClr val="accent1"/>
-          </a:effectRef>
-          <a:fontRef idx="minor">
-            <a:schemeClr val="tx1"/>
-          </a:fontRef>
-        </p:style>
-      </p:cxnSp>
-      <p:cxnSp>
-        <p:nvCxnSpPr>
-          <p:cNvPr id="46" name="Connector 45"/>
-          <p:cNvCxnSpPr/>
-          <p:nvPr/>
-        </p:nvCxnSpPr>
-        <p:spPr>
-          <a:xfrm flipV="1">
-            <a:off x="4052943" y="4355425"/>
-            <a:ext cx="398033" cy="441307"/>
-          </a:xfrm>
-          <a:prstGeom prst="line">
-            <a:avLst/>
-          </a:prstGeom>
-          <a:ln w="25400">
-            <a:solidFill>
-              <a:srgbClr val="1B2533"/>
-            </a:solidFill>
-          </a:ln>
-        </p:spPr>
-        <p:style>
-          <a:lnRef idx="2">
-            <a:schemeClr val="accent1"/>
-          </a:lnRef>
-          <a:fillRef idx="0">
-            <a:schemeClr val="accent1"/>
-          </a:fillRef>
-          <a:effectRef idx="1">
-            <a:schemeClr val="accent1"/>
-          </a:effectRef>
-          <a:fontRef idx="minor">
-            <a:schemeClr val="tx1"/>
-          </a:fontRef>
-        </p:style>
-      </p:cxnSp>
-      <p:cxnSp>
-        <p:nvCxnSpPr>
-          <p:cNvPr id="47" name="Connector 46"/>
-          <p:cNvCxnSpPr/>
-          <p:nvPr/>
-        </p:nvCxnSpPr>
-        <p:spPr>
-          <a:xfrm>
-            <a:off x="4450976" y="4355425"/>
-            <a:ext cx="398033" cy="43039"/>
-          </a:xfrm>
-          <a:prstGeom prst="line">
-            <a:avLst/>
-          </a:prstGeom>
-          <a:ln w="25400">
-            <a:solidFill>
-              <a:srgbClr val="1B2533"/>
-            </a:solidFill>
-          </a:ln>
-        </p:spPr>
-        <p:style>
-          <a:lnRef idx="2">
-            <a:schemeClr val="accent1"/>
-          </a:lnRef>
-          <a:fillRef idx="0">
-            <a:schemeClr val="accent1"/>
-          </a:fillRef>
-          <a:effectRef idx="1">
-            <a:schemeClr val="accent1"/>
-          </a:effectRef>
-          <a:fontRef idx="minor">
-            <a:schemeClr val="tx1"/>
-          </a:fontRef>
-        </p:style>
-      </p:cxnSp>
-      <p:cxnSp>
-        <p:nvCxnSpPr>
-          <p:cNvPr id="48" name="Connector 47"/>
-          <p:cNvCxnSpPr/>
-          <p:nvPr/>
-        </p:nvCxnSpPr>
-        <p:spPr>
-          <a:xfrm flipV="1">
-            <a:off x="4849009" y="4346843"/>
-            <a:ext cx="398033" cy="51621"/>
-          </a:xfrm>
-          <a:prstGeom prst="line">
-            <a:avLst/>
-          </a:prstGeom>
-          <a:ln w="25400">
-            <a:solidFill>
-              <a:srgbClr val="1B2533"/>
-            </a:solidFill>
-          </a:ln>
-        </p:spPr>
-        <p:style>
-          <a:lnRef idx="2">
-            <a:schemeClr val="accent1"/>
-          </a:lnRef>
-          <a:fillRef idx="0">
-            <a:schemeClr val="accent1"/>
-          </a:fillRef>
-          <a:effectRef idx="1">
-            <a:schemeClr val="accent1"/>
-          </a:effectRef>
-          <a:fontRef idx="minor">
-            <a:schemeClr val="tx1"/>
-          </a:fontRef>
-        </p:style>
-      </p:cxnSp>
-      <p:cxnSp>
-        <p:nvCxnSpPr>
-          <p:cNvPr id="49" name="Connector 48"/>
-          <p:cNvCxnSpPr/>
-          <p:nvPr/>
-        </p:nvCxnSpPr>
-        <p:spPr>
-          <a:xfrm>
-            <a:off x="5247042" y="4346843"/>
-            <a:ext cx="398033" cy="291667"/>
-          </a:xfrm>
-          <a:prstGeom prst="line">
-            <a:avLst/>
-          </a:prstGeom>
-          <a:ln w="25400">
-            <a:solidFill>
-              <a:srgbClr val="1B2533"/>
-            </a:solidFill>
-          </a:ln>
-        </p:spPr>
-        <p:style>
-          <a:lnRef idx="2">
-            <a:schemeClr val="accent1"/>
-          </a:lnRef>
-          <a:fillRef idx="0">
-            <a:schemeClr val="accent1"/>
-          </a:fillRef>
-          <a:effectRef idx="1">
-            <a:schemeClr val="accent1"/>
-          </a:effectRef>
-          <a:fontRef idx="minor">
-            <a:schemeClr val="tx1"/>
-          </a:fontRef>
-        </p:style>
-      </p:cxnSp>
-      <p:cxnSp>
-        <p:nvCxnSpPr>
-          <p:cNvPr id="50" name="Connector 49"/>
-          <p:cNvCxnSpPr/>
-          <p:nvPr/>
-        </p:nvCxnSpPr>
-        <p:spPr>
-          <a:xfrm>
-            <a:off x="5645075" y="4638510"/>
-            <a:ext cx="398033" cy="594572"/>
-          </a:xfrm>
-          <a:prstGeom prst="line">
-            <a:avLst/>
-          </a:prstGeom>
-          <a:ln w="25400">
-            <a:solidFill>
-              <a:srgbClr val="1B2533"/>
-            </a:solidFill>
-          </a:ln>
-        </p:spPr>
-        <p:style>
-          <a:lnRef idx="2">
-            <a:schemeClr val="accent1"/>
-          </a:lnRef>
-          <a:fillRef idx="0">
-            <a:schemeClr val="accent1"/>
-          </a:fillRef>
-          <a:effectRef idx="1">
-            <a:schemeClr val="accent1"/>
-          </a:effectRef>
-          <a:fontRef idx="minor">
-            <a:schemeClr val="tx1"/>
-          </a:fontRef>
-        </p:style>
-      </p:cxnSp>
-      <p:cxnSp>
-        <p:nvCxnSpPr>
-          <p:cNvPr id="51" name="Connector 50"/>
-          <p:cNvCxnSpPr/>
-          <p:nvPr/>
-        </p:nvCxnSpPr>
-        <p:spPr>
-          <a:xfrm flipV="1">
-            <a:off x="6043108" y="4356195"/>
-            <a:ext cx="398033" cy="876887"/>
-          </a:xfrm>
-          <a:prstGeom prst="line">
-            <a:avLst/>
-          </a:prstGeom>
-          <a:ln w="25400">
-            <a:solidFill>
-              <a:srgbClr val="1B2533"/>
-            </a:solidFill>
-          </a:ln>
-        </p:spPr>
-        <p:style>
-          <a:lnRef idx="2">
-            <a:schemeClr val="accent1"/>
-          </a:lnRef>
-          <a:fillRef idx="0">
-            <a:schemeClr val="accent1"/>
-          </a:fillRef>
-          <a:effectRef idx="1">
-            <a:schemeClr val="accent1"/>
-          </a:effectRef>
-          <a:fontRef idx="minor">
-            <a:schemeClr val="tx1"/>
-          </a:fontRef>
-        </p:style>
-      </p:cxnSp>
-      <p:cxnSp>
-        <p:nvCxnSpPr>
-          <p:cNvPr id="52" name="Connector 51"/>
-          <p:cNvCxnSpPr/>
-          <p:nvPr/>
-        </p:nvCxnSpPr>
-        <p:spPr>
-          <a:xfrm flipV="1">
-            <a:off x="6441141" y="4038289"/>
-            <a:ext cx="398033" cy="317906"/>
-          </a:xfrm>
-          <a:prstGeom prst="line">
-            <a:avLst/>
-          </a:prstGeom>
-          <a:ln w="25400">
-            <a:solidFill>
-              <a:srgbClr val="1B2533"/>
-            </a:solidFill>
-          </a:ln>
-        </p:spPr>
-        <p:style>
-          <a:lnRef idx="2">
-            <a:schemeClr val="accent1"/>
-          </a:lnRef>
-          <a:fillRef idx="0">
-            <a:schemeClr val="accent1"/>
-          </a:fillRef>
-          <a:effectRef idx="1">
-            <a:schemeClr val="accent1"/>
-          </a:effectRef>
-          <a:fontRef idx="minor">
-            <a:schemeClr val="tx1"/>
-          </a:fontRef>
-        </p:style>
-      </p:cxnSp>
-      <p:cxnSp>
-        <p:nvCxnSpPr>
-          <p:cNvPr id="53" name="Connector 52"/>
-          <p:cNvCxnSpPr/>
-          <p:nvPr/>
-        </p:nvCxnSpPr>
-        <p:spPr>
-          <a:xfrm flipV="1">
-            <a:off x="6839174" y="3538727"/>
-            <a:ext cx="398033" cy="499562"/>
-          </a:xfrm>
-          <a:prstGeom prst="line">
-            <a:avLst/>
-          </a:prstGeom>
-          <a:ln w="25400">
-            <a:solidFill>
-              <a:srgbClr val="1B2533"/>
-            </a:solidFill>
-          </a:ln>
-        </p:spPr>
-        <p:style>
-          <a:lnRef idx="2">
-            <a:schemeClr val="accent1"/>
-          </a:lnRef>
-          <a:fillRef idx="0">
-            <a:schemeClr val="accent1"/>
-          </a:fillRef>
-          <a:effectRef idx="1">
-            <a:schemeClr val="accent1"/>
-          </a:effectRef>
-          <a:fontRef idx="minor">
-            <a:schemeClr val="tx1"/>
-          </a:fontRef>
-        </p:style>
-      </p:cxnSp>
-      <p:cxnSp>
-        <p:nvCxnSpPr>
-          <p:cNvPr id="54" name="Connector 53"/>
-          <p:cNvCxnSpPr/>
-          <p:nvPr/>
-        </p:nvCxnSpPr>
-        <p:spPr>
-          <a:xfrm>
-            <a:off x="7237207" y="3538727"/>
-            <a:ext cx="398033" cy="401894"/>
-          </a:xfrm>
-          <a:prstGeom prst="line">
-            <a:avLst/>
-          </a:prstGeom>
-          <a:ln w="25400">
-            <a:solidFill>
-              <a:srgbClr val="1B2533"/>
-            </a:solidFill>
-          </a:ln>
-        </p:spPr>
-        <p:style>
-          <a:lnRef idx="2">
-            <a:schemeClr val="accent1"/>
-          </a:lnRef>
-          <a:fillRef idx="0">
-            <a:schemeClr val="accent1"/>
-          </a:fillRef>
-          <a:effectRef idx="1">
-            <a:schemeClr val="accent1"/>
-          </a:effectRef>
-          <a:fontRef idx="minor">
-            <a:schemeClr val="tx1"/>
-          </a:fontRef>
-        </p:style>
-      </p:cxnSp>
-      <p:sp>
-        <p:nvSpPr>
-          <p:cNvPr id="55" name="TextBox 54"/>
-          <p:cNvSpPr txBox="1"/>
-          <p:nvPr/>
-        </p:nvSpPr>
-        <p:spPr>
-          <a:xfrm>
-            <a:off x="5897880" y="3154680"/>
-            <a:ext cx="548640" cy="182880"/>
-          </a:xfrm>
-          <a:prstGeom prst="rect">
-            <a:avLst/>
-          </a:prstGeom>
-          <a:noFill/>
-        </p:spPr>
-        <p:txBody>
-          <a:bodyPr wrap="square" anchor="ctr">
-            <a:spAutoFit/>
-          </a:bodyPr>
-          <a:lstStyle/>
-          <a:p>
-            <a:pPr algn="l"/>
-            <a:r>
-              <a:rPr sz="1000" b="1">
-                <a:solidFill>
-                  <a:srgbClr val="00A972"/>
-                </a:solidFill>
-                <a:latin typeface="Aptos"/>
-              </a:rPr>
-              <a:t>Real</a:t>
-            </a:r>
-          </a:p>
-        </p:txBody>
-      </p:sp>
-      <p:sp>
-        <p:nvSpPr>
-          <p:cNvPr id="56" name="TextBox 55"/>
-          <p:cNvSpPr txBox="1"/>
-          <p:nvPr/>
-        </p:nvSpPr>
-        <p:spPr>
-          <a:xfrm>
-            <a:off x="6537960" y="3154680"/>
-            <a:ext cx="731520" cy="182880"/>
-          </a:xfrm>
-          <a:prstGeom prst="rect">
-            <a:avLst/>
-          </a:prstGeom>
-          <a:noFill/>
-        </p:spPr>
-        <p:txBody>
-          <a:bodyPr wrap="square" anchor="ctr">
-            <a:spAutoFit/>
-          </a:bodyPr>
-          <a:lstStyle/>
-          <a:p>
-            <a:pPr algn="l"/>
-            <a:r>
-              <a:rPr sz="1000" b="1">
-                <a:solidFill>
-                  <a:srgbClr val="1B2533"/>
-                </a:solidFill>
-                <a:latin typeface="Aptos"/>
-              </a:rPr>
-              <a:t>Prevista</a:t>
-            </a:r>
-          </a:p>
-        </p:txBody>
-      </p:sp>
-      <p:sp>
-        <p:nvSpPr>
-          <p:cNvPr id="57" name="TextBox 56"/>
-          <p:cNvSpPr txBox="1"/>
-          <p:nvPr/>
-        </p:nvSpPr>
-        <p:spPr>
-          <a:xfrm>
-            <a:off x="868680" y="5715000"/>
-            <a:ext cx="822960" cy="182880"/>
-          </a:xfrm>
-          <a:prstGeom prst="rect">
-            <a:avLst/>
-          </a:prstGeom>
-          <a:noFill/>
-        </p:spPr>
-        <p:txBody>
-          <a:bodyPr wrap="square" anchor="ctr">
-            <a:spAutoFit/>
-          </a:bodyPr>
-          <a:lstStyle/>
-          <a:p>
-            <a:pPr algn="l"/>
-            <a:r>
-              <a:rPr sz="900" b="0">
-                <a:solidFill>
-                  <a:srgbClr val="6B7785"/>
-                </a:solidFill>
-                <a:latin typeface="Aptos"/>
-              </a:rPr>
-              <a:t>2025-01</a:t>
-            </a:r>
-          </a:p>
-        </p:txBody>
-      </p:sp>
-      <p:sp>
-        <p:nvSpPr>
-          <p:cNvPr id="58" name="TextBox 57"/>
-          <p:cNvSpPr txBox="1"/>
-          <p:nvPr/>
-        </p:nvSpPr>
-        <p:spPr>
-          <a:xfrm>
-            <a:off x="6812279" y="5715000"/>
-            <a:ext cx="822960" cy="182880"/>
-          </a:xfrm>
-          <a:prstGeom prst="rect">
-            <a:avLst/>
-          </a:prstGeom>
-          <a:noFill/>
-        </p:spPr>
-        <p:txBody>
-          <a:bodyPr wrap="square" anchor="ctr">
-            <a:spAutoFit/>
-          </a:bodyPr>
-          <a:lstStyle/>
-          <a:p>
-            <a:pPr algn="r"/>
-            <a:r>
-              <a:rPr sz="900" b="0">
-                <a:solidFill>
-                  <a:srgbClr val="6B7785"/>
-                </a:solidFill>
-                <a:latin typeface="Aptos"/>
-              </a:rPr>
-              <a:t>2026-06</a:t>
-            </a:r>
-          </a:p>
-        </p:txBody>
-      </p:sp>
-      <p:sp>
-        <p:nvSpPr>
-          <p:cNvPr id="59" name="Rounded Rectangle 58"/>
-          <p:cNvSpPr/>
-          <p:nvPr/>
-        </p:nvSpPr>
-        <p:spPr>
-          <a:xfrm>
-            <a:off x="7955279" y="3154680"/>
-            <a:ext cx="3429000" cy="2697480"/>
-          </a:xfrm>
-          <a:prstGeom prst="roundRect">
-            <a:avLst/>
-          </a:prstGeom>
-          <a:solidFill>
-            <a:srgbClr val="F5F7F9"/>
-          </a:solidFill>
-          <a:ln w="12700">
-            <a:solidFill>
-              <a:srgbClr val="D9DFE5"/>
-            </a:solidFill>
-          </a:ln>
-        </p:spPr>
-        <p:style>
-          <a:lnRef idx="1">
-            <a:schemeClr val="accent1"/>
-          </a:lnRef>
-          <a:fillRef idx="3">
-            <a:schemeClr val="accent1"/>
-          </a:fillRef>
-          <a:effectRef idx="2">
-            <a:schemeClr val="accent1"/>
-          </a:effectRef>
-          <a:fontRef idx="minor">
-            <a:schemeClr val="lt1"/>
-          </a:fontRef>
-        </p:style>
-        <p:txBody>
-          <a:bodyPr rtlCol="0" anchor="ctr"/>
-          <a:lstStyle/>
-          <a:p>
-            <a:pPr algn="ctr"/>
-          </a:p>
-        </p:txBody>
-      </p:sp>
-      <p:sp>
-        <p:nvSpPr>
-          <p:cNvPr id="60" name="TextBox 59"/>
-          <p:cNvSpPr txBox="1"/>
-          <p:nvPr/>
-        </p:nvSpPr>
-        <p:spPr>
-          <a:xfrm>
-            <a:off x="8229600" y="3401568"/>
-            <a:ext cx="2880360" cy="347472"/>
-          </a:xfrm>
-          <a:prstGeom prst="rect">
-            <a:avLst/>
-          </a:prstGeom>
-          <a:noFill/>
-        </p:spPr>
-        <p:txBody>
-          <a:bodyPr wrap="square" anchor="ctr">
-            <a:spAutoFit/>
-          </a:bodyPr>
-          <a:lstStyle/>
-          <a:p>
-            <a:pPr algn="l"/>
-            <a:r>
-              <a:rPr sz="1600" b="1">
-                <a:solidFill>
-                  <a:srgbClr val="1B2533"/>
-                </a:solidFill>
-                <a:latin typeface="Aptos"/>
-              </a:rPr>
-              <a:t>Lectura ejecutiva</a:t>
-            </a:r>
-          </a:p>
-        </p:txBody>
-      </p:sp>
-      <p:sp>
-        <p:nvSpPr>
-          <p:cNvPr id="61" name="TextBox 60"/>
-          <p:cNvSpPr txBox="1"/>
-          <p:nvPr/>
-        </p:nvSpPr>
-        <p:spPr>
-          <a:xfrm>
-            <a:off x="8229600" y="3840480"/>
-            <a:ext cx="2788920" cy="1600200"/>
-          </a:xfrm>
-          <a:prstGeom prst="rect">
-            <a:avLst/>
-          </a:prstGeom>
-          <a:noFill/>
-        </p:spPr>
-        <p:txBody>
-          <a:bodyPr wrap="square" anchor="t">
-            <a:spAutoFit/>
-          </a:bodyPr>
-          <a:lstStyle/>
-          <a:p>
-            <a:pPr algn="l"/>
-            <a:r>
-              <a:rPr sz="1200" b="0">
-                <a:solidFill>
-                  <a:srgbClr val="6B7785"/>
-                </a:solidFill>
-                <a:latin typeface="Aptos"/>
-              </a:rPr>
-              <a:t>• Estacionalidad solar visible
-• Mes adverso determinista
-• Recuperación posterior a incidencia
-• Drill-down por región e instalación</a:t>
+              <a:t>Pantalla real · ambas series y barras visibles · filtros globales activos</a:t>
             </a:r>
           </a:p>
         </p:txBody>
@@ -14746,8 +12872,8 @@
         </p:nvSpPr>
         <p:spPr>
           <a:xfrm>
-            <a:off x="594360" y="6510528"/>
-            <a:ext cx="5943600" cy="182880"/>
+            <a:off x="1783080" y="786384"/>
+            <a:ext cx="9601200" cy="274320"/>
           </a:xfrm>
           <a:prstGeom prst="rect">
             <a:avLst/>
@@ -14762,6 +12888,41 @@
           <a:p>
             <a:pPr algn="l"/>
             <a:r>
+              <a:rPr sz="1100" b="0">
+                <a:solidFill>
+                  <a:srgbClr val="6B7785"/>
+                </a:solidFill>
+                <a:latin typeface="Aptos"/>
+              </a:rPr>
+              <a:t>Captura real del agente desplegado · fuente semántica gobernada</a:t>
+            </a:r>
+          </a:p>
+        </p:txBody>
+      </p:sp>
+      <p:sp>
+        <p:nvSpPr>
+          <p:cNvPr id="5" name="TextBox 4"/>
+          <p:cNvSpPr txBox="1"/>
+          <p:nvPr/>
+        </p:nvSpPr>
+        <p:spPr>
+          <a:xfrm>
+            <a:off x="594360" y="6510528"/>
+            <a:ext cx="5943600" cy="182880"/>
+          </a:xfrm>
+          <a:prstGeom prst="rect">
+            <a:avLst/>
+          </a:prstGeom>
+          <a:noFill/>
+        </p:spPr>
+        <p:txBody>
+          <a:bodyPr wrap="square" anchor="ctr">
+            <a:spAutoFit/>
+          </a:bodyPr>
+          <a:lstStyle/>
+          <a:p>
+            <a:pPr algn="l"/>
+            <a:r>
               <a:rPr sz="900" b="0">
                 <a:solidFill>
                   <a:srgbClr val="6B7785"/>
@@ -14775,7 +12936,7 @@
       </p:sp>
       <p:sp>
         <p:nvSpPr>
-          <p:cNvPr id="5" name="TextBox 4"/>
+          <p:cNvPr id="6" name="TextBox 5"/>
           <p:cNvSpPr txBox="1"/>
           <p:nvPr/>
         </p:nvSpPr>
@@ -14810,94 +12971,14 @@
       </p:sp>
       <p:sp>
         <p:nvSpPr>
-          <p:cNvPr id="6" name="Rounded Rectangle 5"/>
+          <p:cNvPr id="7" name="Rounded Rectangle 6"/>
           <p:cNvSpPr/>
           <p:nvPr/>
         </p:nvSpPr>
         <p:spPr>
           <a:xfrm>
-            <a:off x="685800" y="1234440"/>
-            <a:ext cx="6583680" cy="4526280"/>
-          </a:xfrm>
-          <a:prstGeom prst="roundRect">
-            <a:avLst/>
-          </a:prstGeom>
-          <a:solidFill>
-            <a:srgbClr val="F5F7F9"/>
-          </a:solidFill>
-          <a:ln w="12700">
-            <a:solidFill>
-              <a:srgbClr val="D9DFE5"/>
-            </a:solidFill>
-          </a:ln>
-        </p:spPr>
-        <p:style>
-          <a:lnRef idx="1">
-            <a:schemeClr val="accent1"/>
-          </a:lnRef>
-          <a:fillRef idx="3">
-            <a:schemeClr val="accent1"/>
-          </a:fillRef>
-          <a:effectRef idx="2">
-            <a:schemeClr val="accent1"/>
-          </a:effectRef>
-          <a:fontRef idx="minor">
-            <a:schemeClr val="lt1"/>
-          </a:fontRef>
-        </p:style>
-        <p:txBody>
-          <a:bodyPr rtlCol="0" anchor="ctr"/>
-          <a:lstStyle/>
-          <a:p>
-            <a:pPr algn="ctr"/>
-          </a:p>
-        </p:txBody>
-      </p:sp>
-      <p:sp>
-        <p:nvSpPr>
-          <p:cNvPr id="7" name="TextBox 6"/>
-          <p:cNvSpPr txBox="1"/>
-          <p:nvPr/>
-        </p:nvSpPr>
-        <p:spPr>
-          <a:xfrm>
-            <a:off x="960120" y="1527048"/>
-            <a:ext cx="914400" cy="274320"/>
-          </a:xfrm>
-          <a:prstGeom prst="rect">
-            <a:avLst/>
-          </a:prstGeom>
-          <a:noFill/>
-        </p:spPr>
-        <p:txBody>
-          <a:bodyPr wrap="square" anchor="ctr">
-            <a:spAutoFit/>
-          </a:bodyPr>
-          <a:lstStyle/>
-          <a:p>
-            <a:pPr algn="l"/>
-            <a:r>
-              <a:rPr sz="1100" b="1">
-                <a:solidFill>
-                  <a:srgbClr val="6B7785"/>
-                </a:solidFill>
-                <a:latin typeface="Aptos"/>
-              </a:rPr>
-              <a:t>Usuario</a:t>
-            </a:r>
-          </a:p>
-        </p:txBody>
-      </p:sp>
-      <p:sp>
-        <p:nvSpPr>
-          <p:cNvPr id="8" name="Rounded Rectangle 7"/>
-          <p:cNvSpPr/>
-          <p:nvPr/>
-        </p:nvSpPr>
-        <p:spPr>
-          <a:xfrm>
-            <a:off x="914400" y="1874519"/>
-            <a:ext cx="5349240" cy="731520"/>
+            <a:off x="594360" y="1115568"/>
+            <a:ext cx="11009376" cy="4946903"/>
           </a:xfrm>
           <a:prstGeom prst="roundRect">
             <a:avLst/>
@@ -14933,6 +13014,30 @@
           </a:p>
         </p:txBody>
       </p:sp>
+      <p:pic>
+        <p:nvPicPr>
+          <p:cNvPr id="8" name="Picture 7" descr="image.png"/>
+          <p:cNvPicPr>
+            <a:picLocks noChangeAspect="1"/>
+          </p:cNvPicPr>
+          <p:nvPr/>
+        </p:nvPicPr>
+        <p:blipFill>
+          <a:blip r:embed="rId2"/>
+          <a:stretch>
+            <a:fillRect/>
+          </a:stretch>
+        </p:blipFill>
+        <p:spPr>
+          <a:xfrm>
+            <a:off x="621792" y="1143000"/>
+            <a:ext cx="10954512" cy="4892040"/>
+          </a:xfrm>
+          <a:prstGeom prst="rect">
+            <a:avLst/>
+          </a:prstGeom>
+        </p:spPr>
+      </p:pic>
       <p:sp>
         <p:nvSpPr>
           <p:cNvPr id="9" name="TextBox 8"/>
@@ -14941,8 +13046,8 @@
         </p:nvSpPr>
         <p:spPr>
           <a:xfrm>
-            <a:off x="1097280" y="1975104"/>
-            <a:ext cx="4983480" cy="475488"/>
+            <a:off x="749808" y="6080760"/>
+            <a:ext cx="10652760" cy="219456"/>
           </a:xfrm>
           <a:prstGeom prst="rect">
             <a:avLst/>
@@ -14955,275 +13060,15 @@
           </a:bodyPr>
           <a:lstStyle/>
           <a:p>
-            <a:pPr algn="l"/>
-            <a:r>
-              <a:rPr sz="1300" b="0">
-                <a:solidFill>
-                  <a:srgbClr val="1B2533"/>
+            <a:pPr algn="ctr"/>
+            <a:r>
+              <a:rPr sz="1000" b="1">
+                <a:solidFill>
+                  <a:srgbClr val="00A972"/>
                 </a:solidFill>
                 <a:latin typeface="Aptos"/>
               </a:rPr>
-              <a:t>¿Qué región tuvo la mayor desviación negativa y en qué periodo?</a:t>
-            </a:r>
-          </a:p>
-        </p:txBody>
-      </p:sp>
-      <p:sp>
-        <p:nvSpPr>
-          <p:cNvPr id="10" name="TextBox 9"/>
-          <p:cNvSpPr txBox="1"/>
-          <p:nvPr/>
-        </p:nvSpPr>
-        <p:spPr>
-          <a:xfrm>
-            <a:off x="960120" y="2880360"/>
-            <a:ext cx="3200400" cy="274320"/>
-          </a:xfrm>
-          <a:prstGeom prst="rect">
-            <a:avLst/>
-          </a:prstGeom>
-          <a:noFill/>
-        </p:spPr>
-        <p:txBody>
-          <a:bodyPr wrap="square" anchor="ctr">
-            <a:spAutoFit/>
-          </a:bodyPr>
-          <a:lstStyle/>
-          <a:p>
-            <a:pPr algn="l"/>
-            <a:r>
-              <a:rPr sz="1100" b="1">
-                <a:solidFill>
-                  <a:srgbClr val="00A972"/>
-                </a:solidFill>
-                <a:latin typeface="Aptos"/>
-              </a:rPr>
-              <a:t>Renewable Operations Analyst</a:t>
-            </a:r>
-          </a:p>
-        </p:txBody>
-      </p:sp>
-      <p:sp>
-        <p:nvSpPr>
-          <p:cNvPr id="11" name="Rounded Rectangle 10"/>
-          <p:cNvSpPr/>
-          <p:nvPr/>
-        </p:nvSpPr>
-        <p:spPr>
-          <a:xfrm>
-            <a:off x="914400" y="3246120"/>
-            <a:ext cx="5897880" cy="1417320"/>
-          </a:xfrm>
-          <a:prstGeom prst="roundRect">
-            <a:avLst/>
-          </a:prstGeom>
-          <a:solidFill>
-            <a:srgbClr val="FFFFFF"/>
-          </a:solidFill>
-          <a:ln w="12700">
-            <a:solidFill>
-              <a:srgbClr val="00A972"/>
-            </a:solidFill>
-          </a:ln>
-        </p:spPr>
-        <p:style>
-          <a:lnRef idx="1">
-            <a:schemeClr val="accent1"/>
-          </a:lnRef>
-          <a:fillRef idx="3">
-            <a:schemeClr val="accent1"/>
-          </a:fillRef>
-          <a:effectRef idx="2">
-            <a:schemeClr val="accent1"/>
-          </a:effectRef>
-          <a:fontRef idx="minor">
-            <a:schemeClr val="lt1"/>
-          </a:fontRef>
-        </p:style>
-        <p:txBody>
-          <a:bodyPr rtlCol="0" anchor="ctr"/>
-          <a:lstStyle/>
-          <a:p>
-            <a:pPr algn="ctr"/>
-          </a:p>
-        </p:txBody>
-      </p:sp>
-      <p:sp>
-        <p:nvSpPr>
-          <p:cNvPr id="12" name="TextBox 11"/>
-          <p:cNvSpPr txBox="1"/>
-          <p:nvPr/>
-        </p:nvSpPr>
-        <p:spPr>
-          <a:xfrm>
-            <a:off x="1143000" y="3401568"/>
-            <a:ext cx="5440680" cy="1078992"/>
-          </a:xfrm>
-          <a:prstGeom prst="rect">
-            <a:avLst/>
-          </a:prstGeom>
-          <a:noFill/>
-        </p:spPr>
-        <p:txBody>
-          <a:bodyPr wrap="square" anchor="t">
-            <a:spAutoFit/>
-          </a:bodyPr>
-          <a:lstStyle/>
-          <a:p>
-            <a:pPr algn="l"/>
-            <a:r>
-              <a:rPr sz="1200" b="0">
-                <a:solidFill>
-                  <a:srgbClr val="6B7785"/>
-                </a:solidFill>
-                <a:latin typeface="Aptos"/>
-              </a:rPr>
-              <a:t>Hallazgo primero
-Periodo y MWh explícitos
-Evidencia desde la métrica gobernada
-Inferencias claramente marcadas</a:t>
-            </a:r>
-          </a:p>
-        </p:txBody>
-      </p:sp>
-      <p:sp>
-        <p:nvSpPr>
-          <p:cNvPr id="13" name="TextBox 12"/>
-          <p:cNvSpPr txBox="1"/>
-          <p:nvPr/>
-        </p:nvSpPr>
-        <p:spPr>
-          <a:xfrm>
-            <a:off x="7818120" y="1463040"/>
-            <a:ext cx="3200400" cy="365760"/>
-          </a:xfrm>
-          <a:prstGeom prst="rect">
-            <a:avLst/>
-          </a:prstGeom>
-          <a:noFill/>
-        </p:spPr>
-        <p:txBody>
-          <a:bodyPr wrap="square" anchor="ctr">
-            <a:spAutoFit/>
-          </a:bodyPr>
-          <a:lstStyle/>
-          <a:p>
-            <a:pPr algn="l"/>
-            <a:r>
-              <a:rPr sz="1700" b="1">
-                <a:solidFill>
-                  <a:srgbClr val="1B2533"/>
-                </a:solidFill>
-                <a:latin typeface="Aptos"/>
-              </a:rPr>
-              <a:t>Consulta libre</a:t>
-            </a:r>
-          </a:p>
-        </p:txBody>
-      </p:sp>
-      <p:sp>
-        <p:nvSpPr>
-          <p:cNvPr id="14" name="TextBox 13"/>
-          <p:cNvSpPr txBox="1"/>
-          <p:nvPr/>
-        </p:nvSpPr>
-        <p:spPr>
-          <a:xfrm>
-            <a:off x="7818120" y="1920240"/>
-            <a:ext cx="3200400" cy="731520"/>
-          </a:xfrm>
-          <a:prstGeom prst="rect">
-            <a:avLst/>
-          </a:prstGeom>
-          <a:noFill/>
-        </p:spPr>
-        <p:txBody>
-          <a:bodyPr wrap="square" anchor="ctr">
-            <a:spAutoFit/>
-          </a:bodyPr>
-          <a:lstStyle/>
-          <a:p>
-            <a:pPr algn="l"/>
-            <a:r>
-              <a:rPr sz="1400" b="0">
-                <a:solidFill>
-                  <a:srgbClr val="6B7785"/>
-                </a:solidFill>
-                <a:latin typeface="Aptos"/>
-              </a:rPr>
-              <a:t>Explora y formula
-una pregunta nueva</a:t>
-            </a:r>
-          </a:p>
-        </p:txBody>
-      </p:sp>
-      <p:sp>
-        <p:nvSpPr>
-          <p:cNvPr id="15" name="TextBox 14"/>
-          <p:cNvSpPr txBox="1"/>
-          <p:nvPr/>
-        </p:nvSpPr>
-        <p:spPr>
-          <a:xfrm>
-            <a:off x="7818120" y="3063240"/>
-            <a:ext cx="3200400" cy="365760"/>
-          </a:xfrm>
-          <a:prstGeom prst="rect">
-            <a:avLst/>
-          </a:prstGeom>
-          <a:noFill/>
-        </p:spPr>
-        <p:txBody>
-          <a:bodyPr wrap="square" anchor="ctr">
-            <a:spAutoFit/>
-          </a:bodyPr>
-          <a:lstStyle/>
-          <a:p>
-            <a:pPr algn="l"/>
-            <a:r>
-              <a:rPr sz="1700" b="1">
-                <a:solidFill>
-                  <a:srgbClr val="00A972"/>
-                </a:solidFill>
-                <a:latin typeface="Aptos"/>
-              </a:rPr>
-              <a:t>Métrica gobernada</a:t>
-            </a:r>
-          </a:p>
-        </p:txBody>
-      </p:sp>
-      <p:sp>
-        <p:nvSpPr>
-          <p:cNvPr id="16" name="TextBox 15"/>
-          <p:cNvSpPr txBox="1"/>
-          <p:nvPr/>
-        </p:nvSpPr>
-        <p:spPr>
-          <a:xfrm>
-            <a:off x="7818120" y="3520440"/>
-            <a:ext cx="3200400" cy="731520"/>
-          </a:xfrm>
-          <a:prstGeom prst="rect">
-            <a:avLst/>
-          </a:prstGeom>
-          <a:noFill/>
-        </p:spPr>
-        <p:txBody>
-          <a:bodyPr wrap="square" anchor="ctr">
-            <a:spAutoFit/>
-          </a:bodyPr>
-          <a:lstStyle/>
-          <a:p>
-            <a:pPr algn="l"/>
-            <a:r>
-              <a:rPr sz="1400" b="0">
-                <a:solidFill>
-                  <a:srgbClr val="6B7785"/>
-                </a:solidFill>
-                <a:latin typeface="Aptos"/>
-              </a:rPr>
-              <a:t>Reutiliza reglas,
-unidades y calendario</a:t>
+              <a:t>Fuente autorizada: workspace.renewable_operations_demo.gg_renewable_operations_metrics</a:t>
             </a:r>
           </a:p>
         </p:txBody>

</xml_diff>

<commit_message>
Complete deployment runbook and delivery hardening
</commit_message>
<xml_diff>
--- a/presentation/renewable_operations_demo.pptx
+++ b/presentation/renewable_operations_demo.pptx
@@ -1208,7 +1208,7 @@
           </a:p>
           <a:p>
             <a:r>
-              <a:t>Transición: Explicamos cómo se comparte correctamente este tipo de demo.</a:t>
+              <a:t>Transición: Pasamos al modelo de acceso y entrega.</a:t>
             </a:r>
           </a:p>
           <a:p>
@@ -1633,7 +1633,7 @@
           </a:p>
           <a:p>
             <a:r>
-              <a:t>Transición: El README contiene los comandos exactos para ambos targets.</a:t>
+              <a:t>Transición: El runbook contiene los comandos exactos para ambos targets.</a:t>
             </a:r>
           </a:p>
           <a:p>
@@ -1713,7 +1713,7 @@
           <a:lstStyle/>
           <a:p>
             <a:r>
-              <a:t>Mensaje principal: Guía para el equipo presentador. Esta diapositiva se mantiene al final para que pueda eliminarse sin alterar la narrativa del cliente.</a:t>
+              <a:t>Mensaje principal: Guía para el equipo presentador. Esta diapositiva se mantiene al final para que pueda eliminarse sin alterar la narrativa principal.</a:t>
             </a:r>
           </a:p>
           <a:p>
@@ -6680,7 +6680,7 @@
                 </a:solidFill>
                 <a:latin typeface="Aptos"/>
               </a:rPr>
-              <a:t>Captura real publicada · filtros globales y KPIs gobernados</a:t>
+              <a:t>Filtros globales y KPIs gobernados</a:t>
             </a:r>
           </a:p>
         </p:txBody>
@@ -7118,7 +7118,7 @@
                 </a:solidFill>
                 <a:latin typeface="Aptos"/>
               </a:rPr>
-              <a:t>Captura real · nombres de instalación explícitos y dimensiones separadas</a:t>
+              <a:t>Nombres de instalación explícitos y dimensiones separadas</a:t>
             </a:r>
           </a:p>
         </p:txBody>
@@ -13294,7 +13294,7 @@
                 </a:solidFill>
                 <a:latin typeface="Aptos"/>
               </a:rPr>
-              <a:t>Recomendación: priorizar la App solo cuando el cliente quiera cerrar el ciclo de acción.</a:t>
+              <a:t>Recomendación: priorizar la App cuando sea necesario cerrar el ciclo de acción.</a:t>
             </a:r>
           </a:p>
         </p:txBody>
@@ -13355,7 +13355,7 @@
                 </a:solidFill>
                 <a:latin typeface="Aptos"/>
               </a:rPr>
-              <a:t>Cómo compartir correctamente el demo</a:t>
+              <a:t>Acceso y entrega de los componentes</a:t>
             </a:r>
           </a:p>
         </p:txBody>
@@ -13433,7 +13433,7 @@
                 </a:solidFill>
                 <a:latin typeface="Aptos"/>
               </a:rPr>
-              <a:t>El canal depende de quién lo recibe y para qué</a:t>
+              <a:t>La forma de acceso depende del rol, el entorno y los permisos</a:t>
             </a:r>
           </a:p>
         </p:txBody>
@@ -16529,7 +16529,7 @@
                 </a:solidFill>
                 <a:latin typeface="Aptos"/>
               </a:rPr>
-              <a:t>Calcula KPI diario y publica Semantic View y Metric View.</a:t>
+              <a:t>Publica KPI, Semantic View y Metric View si está disponible.</a:t>
             </a:r>
           </a:p>
         </p:txBody>
@@ -17504,7 +17504,7 @@
                 </a:solidFill>
                 <a:latin typeface="Aptos"/>
               </a:rPr>
-              <a:t>Pytest: 25 passed · 91 % cobertura</a:t>
+              <a:t>Pytest: 29 passed · 92 % cobertura</a:t>
             </a:r>
           </a:p>
         </p:txBody>
@@ -17644,7 +17644,7 @@
                 </a:solidFill>
                 <a:latin typeface="Aptos"/>
               </a:rPr>
-              <a:t>16 controles remotos</a:t>
+              <a:t>16 DQ + 8 SQL de smoke</a:t>
             </a:r>
           </a:p>
         </p:txBody>
@@ -18873,7 +18873,7 @@
                 </a:solidFill>
                 <a:latin typeface="Aptos"/>
               </a:rPr>
-              <a:t>warehouse existente con CAN USE</a:t>
+              <a:t>warehouse Pro/Serverless con CAN USE</a:t>
             </a:r>
           </a:p>
         </p:txBody>
@@ -19128,7 +19128,7 @@
                 </a:solidFill>
                 <a:latin typeface="Aptos"/>
               </a:rPr>
-              <a:t>Detalle reproducible: README.md · docs.databricks.com/aws/en/dev-tools/bundles/</a:t>
+              <a:t>Detalle reproducible: README.md · docs/deployment_runbook.md</a:t>
             </a:r>
           </a:p>
         </p:txBody>
@@ -19267,7 +19267,7 @@
                 </a:solidFill>
                 <a:latin typeface="Aptos"/>
               </a:rPr>
-              <a:t>Última diapositiva opcional; puede eliminarse antes de compartir la versión con cliente</a:t>
+              <a:t>Última diapositiva opcional; puede eliminarse antes de distribuir la versión final</a:t>
             </a:r>
           </a:p>
         </p:txBody>
@@ -20652,7 +20652,7 @@
                 </a:solidFill>
                 <a:latin typeface="Aptos"/>
               </a:rPr>
-              <a:t>ELIMINAR ESTA DIAPOSITIVA SI EL ARCHIVO SE ENVÍA DIRECTAMENTE AL CLIENTE</a:t>
+              <a:t>ELIMINAR ESTA DIAPOSITIVA ANTES DE DISTRIBUIR LA VERSIÓN FINAL</a:t>
             </a:r>
           </a:p>
         </p:txBody>
@@ -23849,7 +23849,7 @@
                 </a:solidFill>
                 <a:latin typeface="Aptos"/>
               </a:rPr>
-              <a:t>Captura real · sin notebooks, clusters ni SQL como punto de partida</a:t>
+              <a:t>Sin notebooks, clusters ni SQL como punto de partida</a:t>
             </a:r>
           </a:p>
         </p:txBody>

</xml_diff>

<commit_message>
Remove internal slide from public deck
</commit_message>
<xml_diff>
--- a/presentation/renewable_operations_demo.pptx
+++ b/presentation/renewable_operations_demo.pptx
@@ -26,7 +26,6 @@
     <p:sldId id="274" r:id="rId26"/>
     <p:sldId id="275" r:id="rId27"/>
     <p:sldId id="276" r:id="rId28"/>
-    <p:sldId id="277" r:id="rId29"/>
   </p:sldIdLst>
   <p:sldSz cx="12191695" cy="6858000" type="screen4x3"/>
   <p:notesSz cx="6858000" cy="9144000"/>
@@ -1639,91 +1638,6 @@
           <a:p>
             <a:r>
               <a:t>Duración aproximada: 1:20</a:t>
-            </a:r>
-          </a:p>
-          <a:p>
-            <a:r>
-              <a:t>Demostración: N/A</a:t>
-            </a:r>
-          </a:p>
-        </p:txBody>
-      </p:sp>
-      <p:sp>
-        <p:nvSpPr>
-          <p:cNvPr id="4" name="Slide Number Placeholder 3"/>
-          <p:cNvSpPr>
-            <a:spLocks noGrp="1"/>
-          </p:cNvSpPr>
-          <p:nvPr>
-            <p:ph type="sldNum" idx="5" sz="quarter"/>
-          </p:nvPr>
-        </p:nvSpPr>
-        <p:spPr/>
-      </p:sp>
-    </p:spTree>
-  </p:cSld>
-  <p:clrMapOvr>
-    <a:masterClrMapping/>
-  </p:clrMapOvr>
-</p:notes>
-</file>
-
-<file path=ppt/notesSlides/notesSlide22.xml><?xml version="1.0" encoding="utf-8"?>
-<p:notes xmlns:a="http://schemas.openxmlformats.org/drawingml/2006/main" xmlns:p="http://schemas.openxmlformats.org/presentationml/2006/main" xmlns:r="http://schemas.openxmlformats.org/officeDocument/2006/relationships">
-  <p:cSld>
-    <p:spTree>
-      <p:nvGrpSpPr>
-        <p:cNvPr id="1" name=""/>
-        <p:cNvGrpSpPr/>
-        <p:nvPr/>
-      </p:nvGrpSpPr>
-      <p:grpSpPr>
-        <a:xfrm>
-          <a:off x="0" y="0"/>
-          <a:ext cx="0" cy="0"/>
-          <a:chOff x="0" y="0"/>
-          <a:chExt cx="0" cy="0"/>
-        </a:xfrm>
-      </p:grpSpPr>
-      <p:sp>
-        <p:nvSpPr>
-          <p:cNvPr id="2" name="Slide Image Placeholder 1"/>
-          <p:cNvSpPr>
-            <a:spLocks noGrp="1"/>
-          </p:cNvSpPr>
-          <p:nvPr>
-            <p:ph type="sldImg" idx="2"/>
-          </p:nvPr>
-        </p:nvSpPr>
-        <p:spPr/>
-      </p:sp>
-      <p:sp>
-        <p:nvSpPr>
-          <p:cNvPr id="3" name="Notes Placeholder 2"/>
-          <p:cNvSpPr>
-            <a:spLocks noGrp="1"/>
-          </p:cNvSpPr>
-          <p:nvPr>
-            <p:ph type="body" idx="3" sz="quarter"/>
-          </p:nvPr>
-        </p:nvSpPr>
-        <p:spPr/>
-        <p:txBody>
-          <a:bodyPr/>
-          <a:lstStyle/>
-          <a:p>
-            <a:r>
-              <a:t>Mensaje principal: Guía para el equipo presentador. Esta diapositiva se mantiene al final para que pueda eliminarse sin alterar la narrativa principal.</a:t>
-            </a:r>
-          </a:p>
-          <a:p>
-            <a:r>
-              <a:t>Transición: Fin del anexo interno.</a:t>
-            </a:r>
-          </a:p>
-          <a:p>
-            <a:r>
-              <a:t>Duración aproximada: 1:10</a:t>
             </a:r>
           </a:p>
           <a:p>
@@ -19129,1530 +19043,6 @@
                 <a:latin typeface="Aptos"/>
               </a:rPr>
               <a:t>Detalle reproducible: README.md · docs/deployment_runbook.md</a:t>
-            </a:r>
-          </a:p>
-        </p:txBody>
-      </p:sp>
-    </p:spTree>
-  </p:cSld>
-  <p:clrMapOvr>
-    <a:masterClrMapping/>
-  </p:clrMapOvr>
-</p:sld>
-</file>
-
-<file path=ppt/slides/slide22.xml><?xml version="1.0" encoding="utf-8"?>
-<p:sld xmlns:a="http://schemas.openxmlformats.org/drawingml/2006/main" xmlns:p="http://schemas.openxmlformats.org/presentationml/2006/main" xmlns:r="http://schemas.openxmlformats.org/officeDocument/2006/relationships">
-  <p:cSld>
-    <p:bg>
-      <p:bgPr>
-        <a:solidFill>
-          <a:srgbClr val="FFFFFF"/>
-        </a:solidFill>
-        <a:effectLst/>
-      </p:bgPr>
-    </p:bg>
-    <p:spTree>
-      <p:nvGrpSpPr>
-        <p:cNvPr id="1" name=""/>
-        <p:cNvGrpSpPr/>
-        <p:nvPr/>
-      </p:nvGrpSpPr>
-      <p:grpSpPr/>
-      <p:sp>
-        <p:nvSpPr>
-          <p:cNvPr id="2" name="TextBox 1"/>
-          <p:cNvSpPr txBox="1"/>
-          <p:nvPr/>
-        </p:nvSpPr>
-        <p:spPr>
-          <a:xfrm>
-            <a:off x="594360" y="292608"/>
-            <a:ext cx="10881360" cy="502920"/>
-          </a:xfrm>
-          <a:prstGeom prst="rect">
-            <a:avLst/>
-          </a:prstGeom>
-          <a:noFill/>
-        </p:spPr>
-        <p:txBody>
-          <a:bodyPr wrap="square" anchor="ctr">
-            <a:spAutoFit/>
-          </a:bodyPr>
-          <a:lstStyle/>
-          <a:p>
-            <a:pPr algn="l"/>
-            <a:r>
-              <a:rPr sz="2600" b="1">
-                <a:solidFill>
-                  <a:srgbClr val="1B2533"/>
-                </a:solidFill>
-                <a:latin typeface="Aptos"/>
-              </a:rPr>
-              <a:t>Guía interna · recorrido recomendado</a:t>
-            </a:r>
-          </a:p>
-        </p:txBody>
-      </p:sp>
-      <p:sp>
-        <p:nvSpPr>
-          <p:cNvPr id="3" name="Rectangle 2"/>
-          <p:cNvSpPr/>
-          <p:nvPr/>
-        </p:nvSpPr>
-        <p:spPr>
-          <a:xfrm>
-            <a:off x="594360" y="896112"/>
-            <a:ext cx="1005840" cy="54864"/>
-          </a:xfrm>
-          <a:prstGeom prst="rect">
-            <a:avLst/>
-          </a:prstGeom>
-          <a:solidFill>
-            <a:srgbClr val="FF3621"/>
-          </a:solidFill>
-          <a:ln>
-            <a:noFill/>
-          </a:ln>
-        </p:spPr>
-        <p:style>
-          <a:lnRef idx="1">
-            <a:schemeClr val="accent1"/>
-          </a:lnRef>
-          <a:fillRef idx="3">
-            <a:schemeClr val="accent1"/>
-          </a:fillRef>
-          <a:effectRef idx="2">
-            <a:schemeClr val="accent1"/>
-          </a:effectRef>
-          <a:fontRef idx="minor">
-            <a:schemeClr val="lt1"/>
-          </a:fontRef>
-        </p:style>
-        <p:txBody>
-          <a:bodyPr rtlCol="0" anchor="ctr"/>
-          <a:lstStyle/>
-          <a:p>
-            <a:pPr algn="ctr"/>
-          </a:p>
-        </p:txBody>
-      </p:sp>
-      <p:sp>
-        <p:nvSpPr>
-          <p:cNvPr id="4" name="TextBox 3"/>
-          <p:cNvSpPr txBox="1"/>
-          <p:nvPr/>
-        </p:nvSpPr>
-        <p:spPr>
-          <a:xfrm>
-            <a:off x="1783080" y="786384"/>
-            <a:ext cx="9601200" cy="274320"/>
-          </a:xfrm>
-          <a:prstGeom prst="rect">
-            <a:avLst/>
-          </a:prstGeom>
-          <a:noFill/>
-        </p:spPr>
-        <p:txBody>
-          <a:bodyPr wrap="square" anchor="ctr">
-            <a:spAutoFit/>
-          </a:bodyPr>
-          <a:lstStyle/>
-          <a:p>
-            <a:pPr algn="l"/>
-            <a:r>
-              <a:rPr sz="1100" b="0">
-                <a:solidFill>
-                  <a:srgbClr val="6B7785"/>
-                </a:solidFill>
-                <a:latin typeface="Aptos"/>
-              </a:rPr>
-              <a:t>Última diapositiva opcional; puede eliminarse antes de distribuir la versión final</a:t>
-            </a:r>
-          </a:p>
-        </p:txBody>
-      </p:sp>
-      <p:sp>
-        <p:nvSpPr>
-          <p:cNvPr id="5" name="TextBox 4"/>
-          <p:cNvSpPr txBox="1"/>
-          <p:nvPr/>
-        </p:nvSpPr>
-        <p:spPr>
-          <a:xfrm>
-            <a:off x="594360" y="6510528"/>
-            <a:ext cx="5943600" cy="182880"/>
-          </a:xfrm>
-          <a:prstGeom prst="rect">
-            <a:avLst/>
-          </a:prstGeom>
-          <a:noFill/>
-        </p:spPr>
-        <p:txBody>
-          <a:bodyPr wrap="square" anchor="ctr">
-            <a:spAutoFit/>
-          </a:bodyPr>
-          <a:lstStyle/>
-          <a:p>
-            <a:pPr algn="l"/>
-            <a:r>
-              <a:rPr sz="900" b="0">
-                <a:solidFill>
-                  <a:srgbClr val="6B7785"/>
-                </a:solidFill>
-                <a:latin typeface="Aptos"/>
-              </a:rPr>
-              <a:t>Datos exclusivamente sintéticos · Julio 2026</a:t>
-            </a:r>
-          </a:p>
-        </p:txBody>
-      </p:sp>
-      <p:sp>
-        <p:nvSpPr>
-          <p:cNvPr id="6" name="TextBox 5"/>
-          <p:cNvSpPr txBox="1"/>
-          <p:nvPr/>
-        </p:nvSpPr>
-        <p:spPr>
-          <a:xfrm>
-            <a:off x="11064240" y="6510528"/>
-            <a:ext cx="502920" cy="182880"/>
-          </a:xfrm>
-          <a:prstGeom prst="rect">
-            <a:avLst/>
-          </a:prstGeom>
-          <a:noFill/>
-        </p:spPr>
-        <p:txBody>
-          <a:bodyPr wrap="square" anchor="ctr">
-            <a:spAutoFit/>
-          </a:bodyPr>
-          <a:lstStyle/>
-          <a:p>
-            <a:pPr algn="r"/>
-            <a:r>
-              <a:rPr sz="900" b="0">
-                <a:solidFill>
-                  <a:srgbClr val="6B7785"/>
-                </a:solidFill>
-                <a:latin typeface="Aptos"/>
-              </a:rPr>
-              <a:t>22</a:t>
-            </a:r>
-          </a:p>
-        </p:txBody>
-      </p:sp>
-      <p:sp>
-        <p:nvSpPr>
-          <p:cNvPr id="7" name="Rounded Rectangle 6"/>
-          <p:cNvSpPr/>
-          <p:nvPr/>
-        </p:nvSpPr>
-        <p:spPr>
-          <a:xfrm>
-            <a:off x="9966960" y="493776"/>
-            <a:ext cx="1325880" cy="365760"/>
-          </a:xfrm>
-          <a:prstGeom prst="roundRect">
-            <a:avLst/>
-          </a:prstGeom>
-          <a:solidFill>
-            <a:srgbClr val="F39C4A"/>
-          </a:solidFill>
-          <a:ln w="12700">
-            <a:solidFill>
-              <a:srgbClr val="F39C4A"/>
-            </a:solidFill>
-          </a:ln>
-        </p:spPr>
-        <p:style>
-          <a:lnRef idx="1">
-            <a:schemeClr val="accent1"/>
-          </a:lnRef>
-          <a:fillRef idx="3">
-            <a:schemeClr val="accent1"/>
-          </a:fillRef>
-          <a:effectRef idx="2">
-            <a:schemeClr val="accent1"/>
-          </a:effectRef>
-          <a:fontRef idx="minor">
-            <a:schemeClr val="lt1"/>
-          </a:fontRef>
-        </p:style>
-        <p:txBody>
-          <a:bodyPr rtlCol="0" anchor="ctr"/>
-          <a:lstStyle/>
-          <a:p>
-            <a:pPr algn="ctr"/>
-          </a:p>
-        </p:txBody>
-      </p:sp>
-      <p:sp>
-        <p:nvSpPr>
-          <p:cNvPr id="8" name="TextBox 7"/>
-          <p:cNvSpPr txBox="1"/>
-          <p:nvPr/>
-        </p:nvSpPr>
-        <p:spPr>
-          <a:xfrm>
-            <a:off x="10040112" y="512064"/>
-            <a:ext cx="1179576" cy="274320"/>
-          </a:xfrm>
-          <a:prstGeom prst="rect">
-            <a:avLst/>
-          </a:prstGeom>
-          <a:noFill/>
-        </p:spPr>
-        <p:txBody>
-          <a:bodyPr wrap="square" anchor="ctr">
-            <a:spAutoFit/>
-          </a:bodyPr>
-          <a:lstStyle/>
-          <a:p>
-            <a:pPr algn="ctr"/>
-            <a:r>
-              <a:rPr sz="1000" b="1">
-                <a:solidFill>
-                  <a:srgbClr val="FFFFFF"/>
-                </a:solidFill>
-                <a:latin typeface="Aptos"/>
-              </a:rPr>
-              <a:t>USO INTERNO</a:t>
-            </a:r>
-          </a:p>
-        </p:txBody>
-      </p:sp>
-      <p:sp>
-        <p:nvSpPr>
-          <p:cNvPr id="9" name="Rounded Rectangle 8"/>
-          <p:cNvSpPr/>
-          <p:nvPr/>
-        </p:nvSpPr>
-        <p:spPr>
-          <a:xfrm>
-            <a:off x="530352" y="1325880"/>
-            <a:ext cx="2633472" cy="1627632"/>
-          </a:xfrm>
-          <a:prstGeom prst="roundRect">
-            <a:avLst/>
-          </a:prstGeom>
-          <a:solidFill>
-            <a:srgbClr val="F5F7F9"/>
-          </a:solidFill>
-          <a:ln w="12700">
-            <a:solidFill>
-              <a:srgbClr val="FF3621"/>
-            </a:solidFill>
-          </a:ln>
-        </p:spPr>
-        <p:style>
-          <a:lnRef idx="1">
-            <a:schemeClr val="accent1"/>
-          </a:lnRef>
-          <a:fillRef idx="3">
-            <a:schemeClr val="accent1"/>
-          </a:fillRef>
-          <a:effectRef idx="2">
-            <a:schemeClr val="accent1"/>
-          </a:effectRef>
-          <a:fontRef idx="minor">
-            <a:schemeClr val="lt1"/>
-          </a:fontRef>
-        </p:style>
-        <p:txBody>
-          <a:bodyPr rtlCol="0" anchor="ctr"/>
-          <a:lstStyle/>
-          <a:p>
-            <a:pPr algn="ctr"/>
-          </a:p>
-        </p:txBody>
-      </p:sp>
-      <p:sp>
-        <p:nvSpPr>
-          <p:cNvPr id="10" name="TextBox 9"/>
-          <p:cNvSpPr txBox="1"/>
-          <p:nvPr/>
-        </p:nvSpPr>
-        <p:spPr>
-          <a:xfrm>
-            <a:off x="676656" y="1453895"/>
-            <a:ext cx="475488" cy="365760"/>
-          </a:xfrm>
-          <a:prstGeom prst="rect">
-            <a:avLst/>
-          </a:prstGeom>
-          <a:noFill/>
-        </p:spPr>
-        <p:txBody>
-          <a:bodyPr wrap="square" anchor="ctr">
-            <a:spAutoFit/>
-          </a:bodyPr>
-          <a:lstStyle/>
-          <a:p>
-            <a:pPr algn="l"/>
-            <a:r>
-              <a:rPr sz="1500" b="1">
-                <a:solidFill>
-                  <a:srgbClr val="FF3621"/>
-                </a:solidFill>
-                <a:latin typeface="Aptos"/>
-              </a:rPr>
-              <a:t>01</a:t>
-            </a:r>
-          </a:p>
-        </p:txBody>
-      </p:sp>
-      <p:sp>
-        <p:nvSpPr>
-          <p:cNvPr id="11" name="TextBox 10"/>
-          <p:cNvSpPr txBox="1"/>
-          <p:nvPr/>
-        </p:nvSpPr>
-        <p:spPr>
-          <a:xfrm>
-            <a:off x="1243584" y="1453895"/>
-            <a:ext cx="1664208" cy="365760"/>
-          </a:xfrm>
-          <a:prstGeom prst="rect">
-            <a:avLst/>
-          </a:prstGeom>
-          <a:noFill/>
-        </p:spPr>
-        <p:txBody>
-          <a:bodyPr wrap="square" anchor="ctr">
-            <a:spAutoFit/>
-          </a:bodyPr>
-          <a:lstStyle/>
-          <a:p>
-            <a:pPr algn="l"/>
-            <a:r>
-              <a:rPr sz="1400" b="1">
-                <a:solidFill>
-                  <a:srgbClr val="1B2533"/>
-                </a:solidFill>
-                <a:latin typeface="Aptos"/>
-              </a:rPr>
-              <a:t>Contexto</a:t>
-            </a:r>
-          </a:p>
-        </p:txBody>
-      </p:sp>
-      <p:sp>
-        <p:nvSpPr>
-          <p:cNvPr id="12" name="TextBox 11"/>
-          <p:cNvSpPr txBox="1"/>
-          <p:nvPr/>
-        </p:nvSpPr>
-        <p:spPr>
-          <a:xfrm>
-            <a:off x="694944" y="2029967"/>
-            <a:ext cx="2249424" cy="594360"/>
-          </a:xfrm>
-          <a:prstGeom prst="rect">
-            <a:avLst/>
-          </a:prstGeom>
-          <a:noFill/>
-        </p:spPr>
-        <p:txBody>
-          <a:bodyPr wrap="square" anchor="t">
-            <a:spAutoFit/>
-          </a:bodyPr>
-          <a:lstStyle/>
-          <a:p>
-            <a:pPr algn="l"/>
-            <a:r>
-              <a:rPr sz="1050" b="0">
-                <a:solidFill>
-                  <a:srgbClr val="6B7785"/>
-                </a:solidFill>
-                <a:latin typeface="Aptos"/>
-              </a:rPr>
-              <a:t>Explicar objetivo y datos sintéticos</a:t>
-            </a:r>
-          </a:p>
-        </p:txBody>
-      </p:sp>
-      <p:sp>
-        <p:nvSpPr>
-          <p:cNvPr id="13" name="Rounded Rectangle 12"/>
-          <p:cNvSpPr/>
-          <p:nvPr/>
-        </p:nvSpPr>
-        <p:spPr>
-          <a:xfrm>
-            <a:off x="3438144" y="1325880"/>
-            <a:ext cx="2633472" cy="1627632"/>
-          </a:xfrm>
-          <a:prstGeom prst="roundRect">
-            <a:avLst/>
-          </a:prstGeom>
-          <a:solidFill>
-            <a:srgbClr val="F5F7F9"/>
-          </a:solidFill>
-          <a:ln w="12700">
-            <a:solidFill>
-              <a:srgbClr val="1B2533"/>
-            </a:solidFill>
-          </a:ln>
-        </p:spPr>
-        <p:style>
-          <a:lnRef idx="1">
-            <a:schemeClr val="accent1"/>
-          </a:lnRef>
-          <a:fillRef idx="3">
-            <a:schemeClr val="accent1"/>
-          </a:fillRef>
-          <a:effectRef idx="2">
-            <a:schemeClr val="accent1"/>
-          </a:effectRef>
-          <a:fontRef idx="minor">
-            <a:schemeClr val="lt1"/>
-          </a:fontRef>
-        </p:style>
-        <p:txBody>
-          <a:bodyPr rtlCol="0" anchor="ctr"/>
-          <a:lstStyle/>
-          <a:p>
-            <a:pPr algn="ctr"/>
-          </a:p>
-        </p:txBody>
-      </p:sp>
-      <p:sp>
-        <p:nvSpPr>
-          <p:cNvPr id="14" name="TextBox 13"/>
-          <p:cNvSpPr txBox="1"/>
-          <p:nvPr/>
-        </p:nvSpPr>
-        <p:spPr>
-          <a:xfrm>
-            <a:off x="3584448" y="1453895"/>
-            <a:ext cx="475488" cy="365760"/>
-          </a:xfrm>
-          <a:prstGeom prst="rect">
-            <a:avLst/>
-          </a:prstGeom>
-          <a:noFill/>
-        </p:spPr>
-        <p:txBody>
-          <a:bodyPr wrap="square" anchor="ctr">
-            <a:spAutoFit/>
-          </a:bodyPr>
-          <a:lstStyle/>
-          <a:p>
-            <a:pPr algn="l"/>
-            <a:r>
-              <a:rPr sz="1500" b="1">
-                <a:solidFill>
-                  <a:srgbClr val="FF3621"/>
-                </a:solidFill>
-                <a:latin typeface="Aptos"/>
-              </a:rPr>
-              <a:t>02</a:t>
-            </a:r>
-          </a:p>
-        </p:txBody>
-      </p:sp>
-      <p:sp>
-        <p:nvSpPr>
-          <p:cNvPr id="15" name="TextBox 14"/>
-          <p:cNvSpPr txBox="1"/>
-          <p:nvPr/>
-        </p:nvSpPr>
-        <p:spPr>
-          <a:xfrm>
-            <a:off x="4151376" y="1453895"/>
-            <a:ext cx="1664208" cy="365760"/>
-          </a:xfrm>
-          <a:prstGeom prst="rect">
-            <a:avLst/>
-          </a:prstGeom>
-          <a:noFill/>
-        </p:spPr>
-        <p:txBody>
-          <a:bodyPr wrap="square" anchor="ctr">
-            <a:spAutoFit/>
-          </a:bodyPr>
-          <a:lstStyle/>
-          <a:p>
-            <a:pPr algn="l"/>
-            <a:r>
-              <a:rPr sz="1400" b="1">
-                <a:solidFill>
-                  <a:srgbClr val="1B2533"/>
-                </a:solidFill>
-                <a:latin typeface="Aptos"/>
-              </a:rPr>
-              <a:t>KPIs</a:t>
-            </a:r>
-          </a:p>
-        </p:txBody>
-      </p:sp>
-      <p:sp>
-        <p:nvSpPr>
-          <p:cNvPr id="16" name="TextBox 15"/>
-          <p:cNvSpPr txBox="1"/>
-          <p:nvPr/>
-        </p:nvSpPr>
-        <p:spPr>
-          <a:xfrm>
-            <a:off x="3602736" y="2029967"/>
-            <a:ext cx="2249424" cy="594360"/>
-          </a:xfrm>
-          <a:prstGeom prst="rect">
-            <a:avLst/>
-          </a:prstGeom>
-          <a:noFill/>
-        </p:spPr>
-        <p:txBody>
-          <a:bodyPr wrap="square" anchor="t">
-            <a:spAutoFit/>
-          </a:bodyPr>
-          <a:lstStyle/>
-          <a:p>
-            <a:pPr algn="l"/>
-            <a:r>
-              <a:rPr sz="1050" b="0">
-                <a:solidFill>
-                  <a:srgbClr val="6B7785"/>
-                </a:solidFill>
-                <a:latin typeface="Aptos"/>
-              </a:rPr>
-              <a:t>Detectar desviación en Executive Overview</a:t>
-            </a:r>
-          </a:p>
-        </p:txBody>
-      </p:sp>
-      <p:sp>
-        <p:nvSpPr>
-          <p:cNvPr id="17" name="Rounded Rectangle 16"/>
-          <p:cNvSpPr/>
-          <p:nvPr/>
-        </p:nvSpPr>
-        <p:spPr>
-          <a:xfrm>
-            <a:off x="6345936" y="1325880"/>
-            <a:ext cx="2633472" cy="1627632"/>
-          </a:xfrm>
-          <a:prstGeom prst="roundRect">
-            <a:avLst/>
-          </a:prstGeom>
-          <a:solidFill>
-            <a:srgbClr val="F5F7F9"/>
-          </a:solidFill>
-          <a:ln w="12700">
-            <a:solidFill>
-              <a:srgbClr val="00A972"/>
-            </a:solidFill>
-          </a:ln>
-        </p:spPr>
-        <p:style>
-          <a:lnRef idx="1">
-            <a:schemeClr val="accent1"/>
-          </a:lnRef>
-          <a:fillRef idx="3">
-            <a:schemeClr val="accent1"/>
-          </a:fillRef>
-          <a:effectRef idx="2">
-            <a:schemeClr val="accent1"/>
-          </a:effectRef>
-          <a:fontRef idx="minor">
-            <a:schemeClr val="lt1"/>
-          </a:fontRef>
-        </p:style>
-        <p:txBody>
-          <a:bodyPr rtlCol="0" anchor="ctr"/>
-          <a:lstStyle/>
-          <a:p>
-            <a:pPr algn="ctr"/>
-          </a:p>
-        </p:txBody>
-      </p:sp>
-      <p:sp>
-        <p:nvSpPr>
-          <p:cNvPr id="18" name="TextBox 17"/>
-          <p:cNvSpPr txBox="1"/>
-          <p:nvPr/>
-        </p:nvSpPr>
-        <p:spPr>
-          <a:xfrm>
-            <a:off x="6492240" y="1453895"/>
-            <a:ext cx="475488" cy="365760"/>
-          </a:xfrm>
-          <a:prstGeom prst="rect">
-            <a:avLst/>
-          </a:prstGeom>
-          <a:noFill/>
-        </p:spPr>
-        <p:txBody>
-          <a:bodyPr wrap="square" anchor="ctr">
-            <a:spAutoFit/>
-          </a:bodyPr>
-          <a:lstStyle/>
-          <a:p>
-            <a:pPr algn="l"/>
-            <a:r>
-              <a:rPr sz="1500" b="1">
-                <a:solidFill>
-                  <a:srgbClr val="FF3621"/>
-                </a:solidFill>
-                <a:latin typeface="Aptos"/>
-              </a:rPr>
-              <a:t>03</a:t>
-            </a:r>
-          </a:p>
-        </p:txBody>
-      </p:sp>
-      <p:sp>
-        <p:nvSpPr>
-          <p:cNvPr id="19" name="TextBox 18"/>
-          <p:cNvSpPr txBox="1"/>
-          <p:nvPr/>
-        </p:nvSpPr>
-        <p:spPr>
-          <a:xfrm>
-            <a:off x="7059168" y="1453895"/>
-            <a:ext cx="1664208" cy="365760"/>
-          </a:xfrm>
-          <a:prstGeom prst="rect">
-            <a:avLst/>
-          </a:prstGeom>
-          <a:noFill/>
-        </p:spPr>
-        <p:txBody>
-          <a:bodyPr wrap="square" anchor="ctr">
-            <a:spAutoFit/>
-          </a:bodyPr>
-          <a:lstStyle/>
-          <a:p>
-            <a:pPr algn="l"/>
-            <a:r>
-              <a:rPr sz="1400" b="1">
-                <a:solidFill>
-                  <a:srgbClr val="1B2533"/>
-                </a:solidFill>
-                <a:latin typeface="Aptos"/>
-              </a:rPr>
-              <a:t>Diagnóstico</a:t>
-            </a:r>
-          </a:p>
-        </p:txBody>
-      </p:sp>
-      <p:sp>
-        <p:nvSpPr>
-          <p:cNvPr id="20" name="TextBox 19"/>
-          <p:cNvSpPr txBox="1"/>
-          <p:nvPr/>
-        </p:nvSpPr>
-        <p:spPr>
-          <a:xfrm>
-            <a:off x="6510528" y="2029967"/>
-            <a:ext cx="2249424" cy="594360"/>
-          </a:xfrm>
-          <a:prstGeom prst="rect">
-            <a:avLst/>
-          </a:prstGeom>
-          <a:noFill/>
-        </p:spPr>
-        <p:txBody>
-          <a:bodyPr wrap="square" anchor="t">
-            <a:spAutoFit/>
-          </a:bodyPr>
-          <a:lstStyle/>
-          <a:p>
-            <a:pPr algn="l"/>
-            <a:r>
-              <a:rPr sz="1050" b="0">
-                <a:solidFill>
-                  <a:srgbClr val="6B7785"/>
-                </a:solidFill>
-                <a:latin typeface="Aptos"/>
-              </a:rPr>
-              <a:t>Bajar a fiabilidad e instalaciones</a:t>
-            </a:r>
-          </a:p>
-        </p:txBody>
-      </p:sp>
-      <p:sp>
-        <p:nvSpPr>
-          <p:cNvPr id="21" name="Rounded Rectangle 20"/>
-          <p:cNvSpPr/>
-          <p:nvPr/>
-        </p:nvSpPr>
-        <p:spPr>
-          <a:xfrm>
-            <a:off x="9253728" y="1325880"/>
-            <a:ext cx="2633472" cy="1627632"/>
-          </a:xfrm>
-          <a:prstGeom prst="roundRect">
-            <a:avLst/>
-          </a:prstGeom>
-          <a:solidFill>
-            <a:srgbClr val="F5F7F9"/>
-          </a:solidFill>
-          <a:ln w="12700">
-            <a:solidFill>
-              <a:srgbClr val="F39C4A"/>
-            </a:solidFill>
-          </a:ln>
-        </p:spPr>
-        <p:style>
-          <a:lnRef idx="1">
-            <a:schemeClr val="accent1"/>
-          </a:lnRef>
-          <a:fillRef idx="3">
-            <a:schemeClr val="accent1"/>
-          </a:fillRef>
-          <a:effectRef idx="2">
-            <a:schemeClr val="accent1"/>
-          </a:effectRef>
-          <a:fontRef idx="minor">
-            <a:schemeClr val="lt1"/>
-          </a:fontRef>
-        </p:style>
-        <p:txBody>
-          <a:bodyPr rtlCol="0" anchor="ctr"/>
-          <a:lstStyle/>
-          <a:p>
-            <a:pPr algn="ctr"/>
-          </a:p>
-        </p:txBody>
-      </p:sp>
-      <p:sp>
-        <p:nvSpPr>
-          <p:cNvPr id="22" name="TextBox 21"/>
-          <p:cNvSpPr txBox="1"/>
-          <p:nvPr/>
-        </p:nvSpPr>
-        <p:spPr>
-          <a:xfrm>
-            <a:off x="9400032" y="1453895"/>
-            <a:ext cx="475488" cy="365760"/>
-          </a:xfrm>
-          <a:prstGeom prst="rect">
-            <a:avLst/>
-          </a:prstGeom>
-          <a:noFill/>
-        </p:spPr>
-        <p:txBody>
-          <a:bodyPr wrap="square" anchor="ctr">
-            <a:spAutoFit/>
-          </a:bodyPr>
-          <a:lstStyle/>
-          <a:p>
-            <a:pPr algn="l"/>
-            <a:r>
-              <a:rPr sz="1500" b="1">
-                <a:solidFill>
-                  <a:srgbClr val="FF3621"/>
-                </a:solidFill>
-                <a:latin typeface="Aptos"/>
-              </a:rPr>
-              <a:t>04</a:t>
-            </a:r>
-          </a:p>
-        </p:txBody>
-      </p:sp>
-      <p:sp>
-        <p:nvSpPr>
-          <p:cNvPr id="23" name="TextBox 22"/>
-          <p:cNvSpPr txBox="1"/>
-          <p:nvPr/>
-        </p:nvSpPr>
-        <p:spPr>
-          <a:xfrm>
-            <a:off x="9966960" y="1453895"/>
-            <a:ext cx="1664208" cy="365760"/>
-          </a:xfrm>
-          <a:prstGeom prst="rect">
-            <a:avLst/>
-          </a:prstGeom>
-          <a:noFill/>
-        </p:spPr>
-        <p:txBody>
-          <a:bodyPr wrap="square" anchor="ctr">
-            <a:spAutoFit/>
-          </a:bodyPr>
-          <a:lstStyle/>
-          <a:p>
-            <a:pPr algn="l"/>
-            <a:r>
-              <a:rPr sz="1400" b="1">
-                <a:solidFill>
-                  <a:srgbClr val="1B2533"/>
-                </a:solidFill>
-                <a:latin typeface="Aptos"/>
-              </a:rPr>
-              <a:t>Pregunta</a:t>
-            </a:r>
-          </a:p>
-        </p:txBody>
-      </p:sp>
-      <p:sp>
-        <p:nvSpPr>
-          <p:cNvPr id="24" name="TextBox 23"/>
-          <p:cNvSpPr txBox="1"/>
-          <p:nvPr/>
-        </p:nvSpPr>
-        <p:spPr>
-          <a:xfrm>
-            <a:off x="9418320" y="2029967"/>
-            <a:ext cx="2249424" cy="594360"/>
-          </a:xfrm>
-          <a:prstGeom prst="rect">
-            <a:avLst/>
-          </a:prstGeom>
-          <a:noFill/>
-        </p:spPr>
-        <p:txBody>
-          <a:bodyPr wrap="square" anchor="t">
-            <a:spAutoFit/>
-          </a:bodyPr>
-          <a:lstStyle/>
-          <a:p>
-            <a:pPr algn="l"/>
-            <a:r>
-              <a:rPr sz="1050" b="0">
-                <a:solidFill>
-                  <a:srgbClr val="6B7785"/>
-                </a:solidFill>
-                <a:latin typeface="Aptos"/>
-              </a:rPr>
-              <a:t>Consultar los tres riesgos en Genie</a:t>
-            </a:r>
-          </a:p>
-        </p:txBody>
-      </p:sp>
-      <p:sp>
-        <p:nvSpPr>
-          <p:cNvPr id="25" name="Rounded Rectangle 24"/>
-          <p:cNvSpPr/>
-          <p:nvPr/>
-        </p:nvSpPr>
-        <p:spPr>
-          <a:xfrm>
-            <a:off x="530352" y="3383280"/>
-            <a:ext cx="2633472" cy="1627632"/>
-          </a:xfrm>
-          <a:prstGeom prst="roundRect">
-            <a:avLst/>
-          </a:prstGeom>
-          <a:solidFill>
-            <a:srgbClr val="F5F7F9"/>
-          </a:solidFill>
-          <a:ln w="12700">
-            <a:solidFill>
-              <a:srgbClr val="FF3621"/>
-            </a:solidFill>
-          </a:ln>
-        </p:spPr>
-        <p:style>
-          <a:lnRef idx="1">
-            <a:schemeClr val="accent1"/>
-          </a:lnRef>
-          <a:fillRef idx="3">
-            <a:schemeClr val="accent1"/>
-          </a:fillRef>
-          <a:effectRef idx="2">
-            <a:schemeClr val="accent1"/>
-          </a:effectRef>
-          <a:fontRef idx="minor">
-            <a:schemeClr val="lt1"/>
-          </a:fontRef>
-        </p:style>
-        <p:txBody>
-          <a:bodyPr rtlCol="0" anchor="ctr"/>
-          <a:lstStyle/>
-          <a:p>
-            <a:pPr algn="ctr"/>
-          </a:p>
-        </p:txBody>
-      </p:sp>
-      <p:sp>
-        <p:nvSpPr>
-          <p:cNvPr id="26" name="TextBox 25"/>
-          <p:cNvSpPr txBox="1"/>
-          <p:nvPr/>
-        </p:nvSpPr>
-        <p:spPr>
-          <a:xfrm>
-            <a:off x="676656" y="3511296"/>
-            <a:ext cx="475488" cy="365760"/>
-          </a:xfrm>
-          <a:prstGeom prst="rect">
-            <a:avLst/>
-          </a:prstGeom>
-          <a:noFill/>
-        </p:spPr>
-        <p:txBody>
-          <a:bodyPr wrap="square" anchor="ctr">
-            <a:spAutoFit/>
-          </a:bodyPr>
-          <a:lstStyle/>
-          <a:p>
-            <a:pPr algn="l"/>
-            <a:r>
-              <a:rPr sz="1500" b="1">
-                <a:solidFill>
-                  <a:srgbClr val="FF3621"/>
-                </a:solidFill>
-                <a:latin typeface="Aptos"/>
-              </a:rPr>
-              <a:t>05</a:t>
-            </a:r>
-          </a:p>
-        </p:txBody>
-      </p:sp>
-      <p:sp>
-        <p:nvSpPr>
-          <p:cNvPr id="27" name="TextBox 26"/>
-          <p:cNvSpPr txBox="1"/>
-          <p:nvPr/>
-        </p:nvSpPr>
-        <p:spPr>
-          <a:xfrm>
-            <a:off x="1243584" y="3511296"/>
-            <a:ext cx="1664208" cy="365760"/>
-          </a:xfrm>
-          <a:prstGeom prst="rect">
-            <a:avLst/>
-          </a:prstGeom>
-          <a:noFill/>
-        </p:spPr>
-        <p:txBody>
-          <a:bodyPr wrap="square" anchor="ctr">
-            <a:spAutoFit/>
-          </a:bodyPr>
-          <a:lstStyle/>
-          <a:p>
-            <a:pPr algn="l"/>
-            <a:r>
-              <a:rPr sz="1400" b="1">
-                <a:solidFill>
-                  <a:srgbClr val="1B2533"/>
-                </a:solidFill>
-                <a:latin typeface="Aptos"/>
-              </a:rPr>
-              <a:t>Evidencia</a:t>
-            </a:r>
-          </a:p>
-        </p:txBody>
-      </p:sp>
-      <p:sp>
-        <p:nvSpPr>
-          <p:cNvPr id="28" name="TextBox 27"/>
-          <p:cNvSpPr txBox="1"/>
-          <p:nvPr/>
-        </p:nvSpPr>
-        <p:spPr>
-          <a:xfrm>
-            <a:off x="694944" y="4087368"/>
-            <a:ext cx="2249424" cy="594360"/>
-          </a:xfrm>
-          <a:prstGeom prst="rect">
-            <a:avLst/>
-          </a:prstGeom>
-          <a:noFill/>
-        </p:spPr>
-        <p:txBody>
-          <a:bodyPr wrap="square" anchor="t">
-            <a:spAutoFit/>
-          </a:bodyPr>
-          <a:lstStyle/>
-          <a:p>
-            <a:pPr algn="l"/>
-            <a:r>
-              <a:rPr sz="1050" b="0">
-                <a:solidFill>
-                  <a:srgbClr val="6B7785"/>
-                </a:solidFill>
-                <a:latin typeface="Aptos"/>
-              </a:rPr>
-              <a:t>Mostrar SQL, tabla y gráfico</a:t>
-            </a:r>
-          </a:p>
-        </p:txBody>
-      </p:sp>
-      <p:sp>
-        <p:nvSpPr>
-          <p:cNvPr id="29" name="Rounded Rectangle 28"/>
-          <p:cNvSpPr/>
-          <p:nvPr/>
-        </p:nvSpPr>
-        <p:spPr>
-          <a:xfrm>
-            <a:off x="3438144" y="3383280"/>
-            <a:ext cx="2633472" cy="1627632"/>
-          </a:xfrm>
-          <a:prstGeom prst="roundRect">
-            <a:avLst/>
-          </a:prstGeom>
-          <a:solidFill>
-            <a:srgbClr val="F5F7F9"/>
-          </a:solidFill>
-          <a:ln w="12700">
-            <a:solidFill>
-              <a:srgbClr val="1B2533"/>
-            </a:solidFill>
-          </a:ln>
-        </p:spPr>
-        <p:style>
-          <a:lnRef idx="1">
-            <a:schemeClr val="accent1"/>
-          </a:lnRef>
-          <a:fillRef idx="3">
-            <a:schemeClr val="accent1"/>
-          </a:fillRef>
-          <a:effectRef idx="2">
-            <a:schemeClr val="accent1"/>
-          </a:effectRef>
-          <a:fontRef idx="minor">
-            <a:schemeClr val="lt1"/>
-          </a:fontRef>
-        </p:style>
-        <p:txBody>
-          <a:bodyPr rtlCol="0" anchor="ctr"/>
-          <a:lstStyle/>
-          <a:p>
-            <a:pPr algn="ctr"/>
-          </a:p>
-        </p:txBody>
-      </p:sp>
-      <p:sp>
-        <p:nvSpPr>
-          <p:cNvPr id="30" name="TextBox 29"/>
-          <p:cNvSpPr txBox="1"/>
-          <p:nvPr/>
-        </p:nvSpPr>
-        <p:spPr>
-          <a:xfrm>
-            <a:off x="3584448" y="3511296"/>
-            <a:ext cx="475488" cy="365760"/>
-          </a:xfrm>
-          <a:prstGeom prst="rect">
-            <a:avLst/>
-          </a:prstGeom>
-          <a:noFill/>
-        </p:spPr>
-        <p:txBody>
-          <a:bodyPr wrap="square" anchor="ctr">
-            <a:spAutoFit/>
-          </a:bodyPr>
-          <a:lstStyle/>
-          <a:p>
-            <a:pPr algn="l"/>
-            <a:r>
-              <a:rPr sz="1500" b="1">
-                <a:solidFill>
-                  <a:srgbClr val="FF3621"/>
-                </a:solidFill>
-                <a:latin typeface="Aptos"/>
-              </a:rPr>
-              <a:t>06</a:t>
-            </a:r>
-          </a:p>
-        </p:txBody>
-      </p:sp>
-      <p:sp>
-        <p:nvSpPr>
-          <p:cNvPr id="31" name="TextBox 30"/>
-          <p:cNvSpPr txBox="1"/>
-          <p:nvPr/>
-        </p:nvSpPr>
-        <p:spPr>
-          <a:xfrm>
-            <a:off x="4151376" y="3511296"/>
-            <a:ext cx="1664208" cy="365760"/>
-          </a:xfrm>
-          <a:prstGeom prst="rect">
-            <a:avLst/>
-          </a:prstGeom>
-          <a:noFill/>
-        </p:spPr>
-        <p:txBody>
-          <a:bodyPr wrap="square" anchor="ctr">
-            <a:spAutoFit/>
-          </a:bodyPr>
-          <a:lstStyle/>
-          <a:p>
-            <a:pPr algn="l"/>
-            <a:r>
-              <a:rPr sz="1400" b="1">
-                <a:solidFill>
-                  <a:srgbClr val="1B2533"/>
-                </a:solidFill>
-                <a:latin typeface="Aptos"/>
-              </a:rPr>
-              <a:t>Confianza</a:t>
-            </a:r>
-          </a:p>
-        </p:txBody>
-      </p:sp>
-      <p:sp>
-        <p:nvSpPr>
-          <p:cNvPr id="32" name="TextBox 31"/>
-          <p:cNvSpPr txBox="1"/>
-          <p:nvPr/>
-        </p:nvSpPr>
-        <p:spPr>
-          <a:xfrm>
-            <a:off x="3602736" y="4087368"/>
-            <a:ext cx="2249424" cy="594360"/>
-          </a:xfrm>
-          <a:prstGeom prst="rect">
-            <a:avLst/>
-          </a:prstGeom>
-          <a:noFill/>
-        </p:spPr>
-        <p:txBody>
-          <a:bodyPr wrap="square" anchor="t">
-            <a:spAutoFit/>
-          </a:bodyPr>
-          <a:lstStyle/>
-          <a:p>
-            <a:pPr algn="l"/>
-            <a:r>
-              <a:rPr sz="1050" b="0">
-                <a:solidFill>
-                  <a:srgbClr val="6B7785"/>
-                </a:solidFill>
-                <a:latin typeface="Aptos"/>
-              </a:rPr>
-              <a:t>Abrir Benchmark 5/5</a:t>
-            </a:r>
-          </a:p>
-        </p:txBody>
-      </p:sp>
-      <p:sp>
-        <p:nvSpPr>
-          <p:cNvPr id="33" name="Rounded Rectangle 32"/>
-          <p:cNvSpPr/>
-          <p:nvPr/>
-        </p:nvSpPr>
-        <p:spPr>
-          <a:xfrm>
-            <a:off x="6345936" y="3383280"/>
-            <a:ext cx="2633472" cy="1627632"/>
-          </a:xfrm>
-          <a:prstGeom prst="roundRect">
-            <a:avLst/>
-          </a:prstGeom>
-          <a:solidFill>
-            <a:srgbClr val="F5F7F9"/>
-          </a:solidFill>
-          <a:ln w="12700">
-            <a:solidFill>
-              <a:srgbClr val="00A972"/>
-            </a:solidFill>
-          </a:ln>
-        </p:spPr>
-        <p:style>
-          <a:lnRef idx="1">
-            <a:schemeClr val="accent1"/>
-          </a:lnRef>
-          <a:fillRef idx="3">
-            <a:schemeClr val="accent1"/>
-          </a:fillRef>
-          <a:effectRef idx="2">
-            <a:schemeClr val="accent1"/>
-          </a:effectRef>
-          <a:fontRef idx="minor">
-            <a:schemeClr val="lt1"/>
-          </a:fontRef>
-        </p:style>
-        <p:txBody>
-          <a:bodyPr rtlCol="0" anchor="ctr"/>
-          <a:lstStyle/>
-          <a:p>
-            <a:pPr algn="ctr"/>
-          </a:p>
-        </p:txBody>
-      </p:sp>
-      <p:sp>
-        <p:nvSpPr>
-          <p:cNvPr id="34" name="TextBox 33"/>
-          <p:cNvSpPr txBox="1"/>
-          <p:nvPr/>
-        </p:nvSpPr>
-        <p:spPr>
-          <a:xfrm>
-            <a:off x="6492240" y="3511296"/>
-            <a:ext cx="475488" cy="365760"/>
-          </a:xfrm>
-          <a:prstGeom prst="rect">
-            <a:avLst/>
-          </a:prstGeom>
-          <a:noFill/>
-        </p:spPr>
-        <p:txBody>
-          <a:bodyPr wrap="square" anchor="ctr">
-            <a:spAutoFit/>
-          </a:bodyPr>
-          <a:lstStyle/>
-          <a:p>
-            <a:pPr algn="l"/>
-            <a:r>
-              <a:rPr sz="1500" b="1">
-                <a:solidFill>
-                  <a:srgbClr val="FF3621"/>
-                </a:solidFill>
-                <a:latin typeface="Aptos"/>
-              </a:rPr>
-              <a:t>07</a:t>
-            </a:r>
-          </a:p>
-        </p:txBody>
-      </p:sp>
-      <p:sp>
-        <p:nvSpPr>
-          <p:cNvPr id="35" name="TextBox 34"/>
-          <p:cNvSpPr txBox="1"/>
-          <p:nvPr/>
-        </p:nvSpPr>
-        <p:spPr>
-          <a:xfrm>
-            <a:off x="7059168" y="3511296"/>
-            <a:ext cx="1664208" cy="365760"/>
-          </a:xfrm>
-          <a:prstGeom prst="rect">
-            <a:avLst/>
-          </a:prstGeom>
-          <a:noFill/>
-        </p:spPr>
-        <p:txBody>
-          <a:bodyPr wrap="square" anchor="ctr">
-            <a:spAutoFit/>
-          </a:bodyPr>
-          <a:lstStyle/>
-          <a:p>
-            <a:pPr algn="l"/>
-            <a:r>
-              <a:rPr sz="1400" b="1">
-                <a:solidFill>
-                  <a:srgbClr val="1B2533"/>
-                </a:solidFill>
-                <a:latin typeface="Aptos"/>
-              </a:rPr>
-              <a:t>Escala</a:t>
-            </a:r>
-          </a:p>
-        </p:txBody>
-      </p:sp>
-      <p:sp>
-        <p:nvSpPr>
-          <p:cNvPr id="36" name="TextBox 35"/>
-          <p:cNvSpPr txBox="1"/>
-          <p:nvPr/>
-        </p:nvSpPr>
-        <p:spPr>
-          <a:xfrm>
-            <a:off x="6510528" y="4087368"/>
-            <a:ext cx="2249424" cy="594360"/>
-          </a:xfrm>
-          <a:prstGeom prst="rect">
-            <a:avLst/>
-          </a:prstGeom>
-          <a:noFill/>
-        </p:spPr>
-        <p:txBody>
-          <a:bodyPr wrap="square" anchor="t">
-            <a:spAutoFit/>
-          </a:bodyPr>
-          <a:lstStyle/>
-          <a:p>
-            <a:pPr algn="l"/>
-            <a:r>
-              <a:rPr sz="1050" b="0">
-                <a:solidFill>
-                  <a:srgbClr val="6B7785"/>
-                </a:solidFill>
-                <a:latin typeface="Aptos"/>
-              </a:rPr>
-              <a:t>Enseñar Genie One y compartir</a:t>
-            </a:r>
-          </a:p>
-        </p:txBody>
-      </p:sp>
-      <p:sp>
-        <p:nvSpPr>
-          <p:cNvPr id="37" name="Rounded Rectangle 36"/>
-          <p:cNvSpPr/>
-          <p:nvPr/>
-        </p:nvSpPr>
-        <p:spPr>
-          <a:xfrm>
-            <a:off x="9253728" y="3383280"/>
-            <a:ext cx="2633472" cy="1627632"/>
-          </a:xfrm>
-          <a:prstGeom prst="roundRect">
-            <a:avLst/>
-          </a:prstGeom>
-          <a:solidFill>
-            <a:srgbClr val="F5F7F9"/>
-          </a:solidFill>
-          <a:ln w="12700">
-            <a:solidFill>
-              <a:srgbClr val="F39C4A"/>
-            </a:solidFill>
-          </a:ln>
-        </p:spPr>
-        <p:style>
-          <a:lnRef idx="1">
-            <a:schemeClr val="accent1"/>
-          </a:lnRef>
-          <a:fillRef idx="3">
-            <a:schemeClr val="accent1"/>
-          </a:fillRef>
-          <a:effectRef idx="2">
-            <a:schemeClr val="accent1"/>
-          </a:effectRef>
-          <a:fontRef idx="minor">
-            <a:schemeClr val="lt1"/>
-          </a:fontRef>
-        </p:style>
-        <p:txBody>
-          <a:bodyPr rtlCol="0" anchor="ctr"/>
-          <a:lstStyle/>
-          <a:p>
-            <a:pPr algn="ctr"/>
-          </a:p>
-        </p:txBody>
-      </p:sp>
-      <p:sp>
-        <p:nvSpPr>
-          <p:cNvPr id="38" name="TextBox 37"/>
-          <p:cNvSpPr txBox="1"/>
-          <p:nvPr/>
-        </p:nvSpPr>
-        <p:spPr>
-          <a:xfrm>
-            <a:off x="9400032" y="3511296"/>
-            <a:ext cx="475488" cy="365760"/>
-          </a:xfrm>
-          <a:prstGeom prst="rect">
-            <a:avLst/>
-          </a:prstGeom>
-          <a:noFill/>
-        </p:spPr>
-        <p:txBody>
-          <a:bodyPr wrap="square" anchor="ctr">
-            <a:spAutoFit/>
-          </a:bodyPr>
-          <a:lstStyle/>
-          <a:p>
-            <a:pPr algn="l"/>
-            <a:r>
-              <a:rPr sz="1500" b="1">
-                <a:solidFill>
-                  <a:srgbClr val="FF3621"/>
-                </a:solidFill>
-                <a:latin typeface="Aptos"/>
-              </a:rPr>
-              <a:t>08</a:t>
-            </a:r>
-          </a:p>
-        </p:txBody>
-      </p:sp>
-      <p:sp>
-        <p:nvSpPr>
-          <p:cNvPr id="39" name="TextBox 38"/>
-          <p:cNvSpPr txBox="1"/>
-          <p:nvPr/>
-        </p:nvSpPr>
-        <p:spPr>
-          <a:xfrm>
-            <a:off x="9966960" y="3511296"/>
-            <a:ext cx="1664208" cy="365760"/>
-          </a:xfrm>
-          <a:prstGeom prst="rect">
-            <a:avLst/>
-          </a:prstGeom>
-          <a:noFill/>
-        </p:spPr>
-        <p:txBody>
-          <a:bodyPr wrap="square" anchor="ctr">
-            <a:spAutoFit/>
-          </a:bodyPr>
-          <a:lstStyle/>
-          <a:p>
-            <a:pPr algn="l"/>
-            <a:r>
-              <a:rPr sz="1400" b="1">
-                <a:solidFill>
-                  <a:srgbClr val="1B2533"/>
-                </a:solidFill>
-                <a:latin typeface="Aptos"/>
-              </a:rPr>
-              <a:t>Acción</a:t>
-            </a:r>
-          </a:p>
-        </p:txBody>
-      </p:sp>
-      <p:sp>
-        <p:nvSpPr>
-          <p:cNvPr id="40" name="TextBox 39"/>
-          <p:cNvSpPr txBox="1"/>
-          <p:nvPr/>
-        </p:nvSpPr>
-        <p:spPr>
-          <a:xfrm>
-            <a:off x="9418320" y="4087368"/>
-            <a:ext cx="2249424" cy="594360"/>
-          </a:xfrm>
-          <a:prstGeom prst="rect">
-            <a:avLst/>
-          </a:prstGeom>
-          <a:noFill/>
-        </p:spPr>
-        <p:txBody>
-          <a:bodyPr wrap="square" anchor="t">
-            <a:spAutoFit/>
-          </a:bodyPr>
-          <a:lstStyle/>
-          <a:p>
-            <a:pPr algn="l"/>
-            <a:r>
-              <a:rPr sz="1050" b="0">
-                <a:solidFill>
-                  <a:srgbClr val="6B7785"/>
-                </a:solidFill>
-                <a:latin typeface="Aptos"/>
-              </a:rPr>
-              <a:t>Proponer App como siguiente paso</a:t>
-            </a:r>
-          </a:p>
-        </p:txBody>
-      </p:sp>
-      <p:sp>
-        <p:nvSpPr>
-          <p:cNvPr id="41" name="TextBox 40"/>
-          <p:cNvSpPr txBox="1"/>
-          <p:nvPr/>
-        </p:nvSpPr>
-        <p:spPr>
-          <a:xfrm>
-            <a:off x="1234440" y="5696712"/>
-            <a:ext cx="9738360" cy="411480"/>
-          </a:xfrm>
-          <a:prstGeom prst="rect">
-            <a:avLst/>
-          </a:prstGeom>
-          <a:noFill/>
-        </p:spPr>
-        <p:txBody>
-          <a:bodyPr wrap="square" anchor="ctr">
-            <a:spAutoFit/>
-          </a:bodyPr>
-          <a:lstStyle/>
-          <a:p>
-            <a:pPr algn="ctr"/>
-            <a:r>
-              <a:rPr sz="1400" b="1">
-                <a:solidFill>
-                  <a:srgbClr val="FF3621"/>
-                </a:solidFill>
-                <a:latin typeface="Aptos"/>
-              </a:rPr>
-              <a:t>ELIMINAR ESTA DIAPOSITIVA ANTES DE DISTRIBUIR LA VERSIÓN FINAL</a:t>
             </a:r>
           </a:p>
         </p:txBody>

</xml_diff>

<commit_message>
Clarify Genie One scope and improve deliverables
</commit_message>
<xml_diff>
--- a/presentation/renewable_operations_demo.pptx
+++ b/presentation/renewable_operations_demo.pptx
@@ -2057,7 +2057,7 @@
           </a:p>
           <a:p>
             <a:r>
-              <a:t>Transición: La siguiente lámina lo convierte en una visión visual de extremo a extremo.</a:t>
+              <a:t>Transición: La siguiente lámina representa el flujo analítico implementado.</a:t>
             </a:r>
           </a:p>
           <a:p>
@@ -12788,7 +12788,7 @@
                 </a:solidFill>
                 <a:latin typeface="Aptos"/>
               </a:rPr>
-              <a:t>App operativa</a:t>
+              <a:t>Domains</a:t>
             </a:r>
           </a:p>
         </p:txBody>
@@ -12823,7 +12823,7 @@
                 </a:solidFill>
                 <a:latin typeface="Aptos"/>
               </a:rPr>
-              <a:t>Insight → workflow/acción</a:t>
+              <a:t>Descubrimiento por contexto de negocio</a:t>
             </a:r>
           </a:p>
         </p:txBody>
@@ -12858,7 +12858,7 @@
                 </a:solidFill>
                 <a:latin typeface="Aptos"/>
               </a:rPr>
-              <a:t>Agent mode</a:t>
+              <a:t>Customizations</a:t>
             </a:r>
           </a:p>
         </p:txBody>
@@ -12893,7 +12893,7 @@
                 </a:solidFill>
                 <a:latin typeface="Aptos"/>
               </a:rPr>
-              <a:t>Investigaciones multiconsulta</a:t>
+              <a:t>Branding, contenido fijado y Skills</a:t>
             </a:r>
           </a:p>
         </p:txBody>
@@ -12928,7 +12928,7 @@
                 </a:solidFill>
                 <a:latin typeface="Aptos"/>
               </a:rPr>
-              <a:t>Archivos en Volumes</a:t>
+              <a:t>Connections</a:t>
             </a:r>
           </a:p>
         </p:txBody>
@@ -12963,7 +12963,7 @@
                 </a:solidFill>
                 <a:latin typeface="Aptos"/>
               </a:rPr>
-              <a:t>Cruzar datos y documentos</a:t>
+              <a:t>Drive, Slack, Microsoft 365…</a:t>
             </a:r>
           </a:p>
         </p:txBody>
@@ -12998,7 +12998,7 @@
                 </a:solidFill>
                 <a:latin typeface="Aptos"/>
               </a:rPr>
-              <a:t>Conexiones externas</a:t>
+              <a:t>App operativa</a:t>
             </a:r>
           </a:p>
         </p:txBody>
@@ -13033,7 +13033,7 @@
                 </a:solidFill>
                 <a:latin typeface="Aptos"/>
               </a:rPr>
-              <a:t>Drive, Slack, Microsoft 365…</a:t>
+              <a:t>Insight → workflow/acción</a:t>
             </a:r>
           </a:p>
         </p:txBody>
@@ -13068,7 +13068,7 @@
                 </a:solidFill>
                 <a:latin typeface="Aptos"/>
               </a:rPr>
-              <a:t>Companion Genie</a:t>
+              <a:t>Agent mode</a:t>
             </a:r>
           </a:p>
         </p:txBody>
@@ -13103,7 +13103,7 @@
                 </a:solidFill>
                 <a:latin typeface="Aptos"/>
               </a:rPr>
-              <a:t>Exploración desde el dashboard</a:t>
+              <a:t>Investigaciones multiconsulta</a:t>
             </a:r>
           </a:p>
         </p:txBody>
@@ -22043,7 +22043,7 @@
         </p:nvSpPr>
         <p:spPr>
           <a:xfrm>
-            <a:off x="1280160" y="5577840"/>
+            <a:off x="1280160" y="5422392"/>
             <a:ext cx="9646920" cy="384048"/>
           </a:xfrm>
           <a:prstGeom prst="rect">
@@ -22059,7 +22059,7 @@
           <a:p>
             <a:pPr algn="ctr"/>
             <a:r>
-              <a:rPr sz="1700" b="1">
+              <a:rPr sz="1600" b="1">
                 <a:solidFill>
                   <a:srgbClr val="00A972"/>
                 </a:solidFill>
@@ -22073,6 +22073,41 @@
       <p:sp>
         <p:nvSpPr>
           <p:cNvPr id="23" name="TextBox 22"/>
+          <p:cNvSpPr txBox="1"/>
+          <p:nvPr/>
+        </p:nvSpPr>
+        <p:spPr>
+          <a:xfrm>
+            <a:off x="1280160" y="5833872"/>
+            <a:ext cx="9646920" cy="274320"/>
+          </a:xfrm>
+          <a:prstGeom prst="rect">
+            <a:avLst/>
+          </a:prstGeom>
+          <a:noFill/>
+        </p:spPr>
+        <p:txBody>
+          <a:bodyPr wrap="square" anchor="ctr">
+            <a:spAutoFit/>
+          </a:bodyPr>
+          <a:lstStyle/>
+          <a:p>
+            <a:pPr algn="ctr"/>
+            <a:r>
+              <a:rPr sz="1100" b="1">
+                <a:solidFill>
+                  <a:srgbClr val="F39C4A"/>
+                </a:solidFill>
+                <a:latin typeface="Aptos"/>
+              </a:rPr>
+              <a:t>Fuera de alcance: Domains, Customizations y Databricks Apps.</a:t>
+            </a:r>
+          </a:p>
+        </p:txBody>
+      </p:sp>
+      <p:sp>
+        <p:nvSpPr>
+          <p:cNvPr id="24" name="TextBox 23"/>
           <p:cNvSpPr txBox="1"/>
           <p:nvPr/>
         </p:nvSpPr>
@@ -22501,7 +22536,7 @@
                 </a:solidFill>
                 <a:latin typeface="Aptos"/>
               </a:rPr>
-              <a:t>Preguntar</a:t>
+              <a:t>Validado · Preguntar</a:t>
             </a:r>
           </a:p>
         </p:txBody>
@@ -22659,7 +22694,7 @@
                 </a:solidFill>
                 <a:latin typeface="Aptos"/>
               </a:rPr>
-              <a:t>Descubrir</a:t>
+              <a:t>Validado · Descubrir</a:t>
             </a:r>
           </a:p>
         </p:txBody>
@@ -22694,7 +22729,7 @@
                 </a:solidFill>
                 <a:latin typeface="Aptos"/>
               </a:rPr>
-              <a:t>Agents, dashboards y dominios compartidos.</a:t>
+              <a:t>Genie Agent y dashboard compartidos.</a:t>
             </a:r>
           </a:p>
         </p:txBody>
@@ -22817,7 +22852,7 @@
                 </a:solidFill>
                 <a:latin typeface="Aptos"/>
               </a:rPr>
-              <a:t>Consumir</a:t>
+              <a:t>No probado · Organizar</a:t>
             </a:r>
           </a:p>
         </p:txBody>
@@ -22852,7 +22887,7 @@
                 </a:solidFill>
                 <a:latin typeface="Aptos"/>
               </a:rPr>
-              <a:t>Apps y tareas sin cambiar de experiencia.</a:t>
+              <a:t>Domains y subdominios de negocio.</a:t>
             </a:r>
           </a:p>
         </p:txBody>
@@ -22975,7 +23010,7 @@
                 </a:solidFill>
                 <a:latin typeface="Aptos"/>
               </a:rPr>
-              <a:t>Movilidad</a:t>
+              <a:t>No probado · Extender</a:t>
             </a:r>
           </a:p>
         </p:txBody>
@@ -23010,7 +23045,7 @@
                 </a:solidFill>
                 <a:latin typeface="Aptos"/>
               </a:rPr>
-              <a:t>Experiencia disponible también en móvil.</a:t>
+              <a:t>Customizations, Apps y Connections.</a:t>
             </a:r>
           </a:p>
         </p:txBody>
@@ -24168,13 +24203,13 @@
           <a:p>
             <a:pPr algn="ctr"/>
             <a:r>
-              <a:rPr sz="1200" b="1">
+              <a:rPr sz="1050" b="1">
                 <a:solidFill>
                   <a:srgbClr val="FFFFFF"/>
                 </a:solidFill>
                 <a:latin typeface="Aptos"/>
               </a:rPr>
-              <a:t>GENIE ONE · consumo por usuarios de negocio  |  APP operativa · extensión opcional</a:t>
+              <a:t>VALIDADO · consumo desde Genie One  |  FUERA DE ALCANCE · Domains · Customizations · Apps</a:t>
             </a:r>
           </a:p>
         </p:txBody>

</xml_diff>